<commit_message>
fix(slides): KOEA-8271 — regenerate mcp-from-first-principles ch02-slides.pptx
- Add scripts/build-mcp-ch02-slides.py: curated build script (patterned
  after build-ch04-slides.py) with manually authored bullets, all <100 chars
- All 7 text truncations fixed: no more mid-word/mid-sentence cutoffs
- All wikilink/footnote notation removed: [[JSON-RPC 2.0]][^1] → plain text
  with live URLs in reference bullets (slides 3, 4, 5)
- Slide 7 CTA updated to "Try It Next" with correct ch02 exercise callout
- 7-slide count preserved: title + 5 content + CTA

Live URLs cited:
  - Slide 3: https://www.jsonrpc.org/specification
  - Slide 4: https://spec.modelcontextprotocol.io/specification/2025-03-26/basic/transports/
  - Slide 5: https://spec.modelcontextprotocol.io/specification/2025-03-26/

Co-Authored-By: Claude Sonnet 4.6 <noreply@anthropic.com>
</commit_message>
<xml_diff>
--- a/vault/courses/mcp-from-first-principles-to-production/ch02-slides.pptx
+++ b/vault/courses/mcp-from-first-principles-to-production/ch02-slides.pptx
@@ -3087,14 +3087,6 @@
 <file path=ppt/slides/slide1.xml><?xml version="1.0" encoding="utf-8"?>
 <p:sld xmlns:a="http://schemas.openxmlformats.org/drawingml/2006/main" xmlns:p="http://schemas.openxmlformats.org/presentationml/2006/main" xmlns:r="http://schemas.openxmlformats.org/officeDocument/2006/relationships">
   <p:cSld>
-    <p:bg>
-      <p:bgPr>
-        <a:solidFill>
-          <a:srgbClr val="18181B"/>
-        </a:solidFill>
-        <a:effectLst/>
-      </p:bgPr>
-    </p:bg>
     <p:spTree>
       <p:nvGrpSpPr>
         <p:cNvPr id="1" name=""/>
@@ -3104,148 +3096,20 @@
       <p:grpSpPr/>
       <p:sp>
         <p:nvSpPr>
-          <p:cNvPr id="2" name="TextBox 1"/>
-          <p:cNvSpPr txBox="1"/>
-          <p:nvPr/>
-        </p:nvSpPr>
-        <p:spPr>
-          <a:xfrm>
-            <a:off x="914400" y="1828800"/>
-            <a:ext cx="10332720" cy="2286000"/>
-          </a:xfrm>
-          <a:prstGeom prst="rect">
-            <a:avLst/>
-          </a:prstGeom>
-          <a:noFill/>
-        </p:spPr>
-        <p:txBody>
-          <a:bodyPr wrap="square">
-            <a:spAutoFit/>
-          </a:bodyPr>
-          <a:lstStyle/>
-          <a:p>
-            <a:pPr algn="ctr"/>
-            <a:r>
-              <a:rPr sz="3400" b="1">
-                <a:solidFill>
-                  <a:srgbClr val="FFFFFF"/>
-                </a:solidFill>
-              </a:rPr>
-              <a:t>JSON-RPC over stdio — the wire protocol explained</a:t>
-            </a:r>
-          </a:p>
-        </p:txBody>
-      </p:sp>
-      <p:sp>
-        <p:nvSpPr>
-          <p:cNvPr id="3" name="TextBox 2"/>
-          <p:cNvSpPr txBox="1"/>
-          <p:nvPr/>
-        </p:nvSpPr>
-        <p:spPr>
-          <a:xfrm>
-            <a:off x="731520" y="6263640"/>
-            <a:ext cx="10698480" cy="365760"/>
-          </a:xfrm>
-          <a:prstGeom prst="rect">
-            <a:avLst/>
-          </a:prstGeom>
-          <a:noFill/>
-        </p:spPr>
-        <p:txBody>
-          <a:bodyPr wrap="square">
-            <a:spAutoFit/>
-          </a:bodyPr>
-          <a:lstStyle/>
-          <a:p>
-            <a:pPr algn="l"/>
-            <a:r>
-              <a:rPr sz="1000" b="0">
-                <a:solidFill>
-                  <a:srgbClr val="A1A1AA"/>
-                </a:solidFill>
-              </a:rPr>
-              <a:t>academy.kspl.tech | Koenig AI Academy</a:t>
-            </a:r>
-          </a:p>
-        </p:txBody>
-      </p:sp>
-    </p:spTree>
-  </p:cSld>
-  <p:clrMapOvr>
-    <a:masterClrMapping/>
-  </p:clrMapOvr>
-</p:sld>
-</file>
-
-<file path=ppt/slides/slide2.xml><?xml version="1.0" encoding="utf-8"?>
-<p:sld xmlns:a="http://schemas.openxmlformats.org/drawingml/2006/main" xmlns:p="http://schemas.openxmlformats.org/presentationml/2006/main" xmlns:r="http://schemas.openxmlformats.org/officeDocument/2006/relationships">
-  <p:cSld>
-    <p:bg>
-      <p:bgPr>
-        <a:solidFill>
-          <a:srgbClr val="18181B"/>
-        </a:solidFill>
-        <a:effectLst/>
-      </p:bgPr>
-    </p:bg>
-    <p:spTree>
-      <p:nvGrpSpPr>
-        <p:cNvPr id="1" name=""/>
-        <p:cNvGrpSpPr/>
-        <p:nvPr/>
-      </p:nvGrpSpPr>
-      <p:grpSpPr/>
-      <p:sp>
-        <p:nvSpPr>
-          <p:cNvPr id="2" name="TextBox 1"/>
-          <p:cNvSpPr txBox="1"/>
-          <p:nvPr/>
-        </p:nvSpPr>
-        <p:spPr>
-          <a:xfrm>
-            <a:off x="731520" y="411480"/>
-            <a:ext cx="10698480" cy="1005840"/>
-          </a:xfrm>
-          <a:prstGeom prst="rect">
-            <a:avLst/>
-          </a:prstGeom>
-          <a:noFill/>
-        </p:spPr>
-        <p:txBody>
-          <a:bodyPr wrap="square">
-            <a:spAutoFit/>
-          </a:bodyPr>
-          <a:lstStyle/>
-          <a:p>
-            <a:pPr algn="l"/>
-            <a:r>
-              <a:rPr sz="2800" b="1">
-                <a:solidFill>
-                  <a:srgbClr val="FFFFFF"/>
-                </a:solidFill>
-              </a:rPr>
-              <a:t>Why the wire format matters</a:t>
-            </a:r>
-          </a:p>
-        </p:txBody>
-      </p:sp>
-      <p:sp>
-        <p:nvSpPr>
-          <p:cNvPr id="3" name="Rectangle 2"/>
+          <p:cNvPr id="2" name="Rectangle 1"/>
           <p:cNvSpPr/>
           <p:nvPr/>
         </p:nvSpPr>
         <p:spPr>
           <a:xfrm>
-            <a:off x="731520" y="1417320"/>
-            <a:ext cx="10698480" cy="36576"/>
+            <a:off x="0" y="0"/>
+            <a:ext cx="12191695" cy="6858000"/>
           </a:xfrm>
           <a:prstGeom prst="rect">
             <a:avLst/>
           </a:prstGeom>
           <a:solidFill>
-            <a:srgbClr val="A1A1AA"/>
+            <a:srgbClr val="18181B"/>
           </a:solidFill>
           <a:ln>
             <a:noFill/>
@@ -3275,216 +3139,20 @@
       </p:sp>
       <p:sp>
         <p:nvSpPr>
-          <p:cNvPr id="4" name="TextBox 3"/>
-          <p:cNvSpPr txBox="1"/>
-          <p:nvPr/>
-        </p:nvSpPr>
-        <p:spPr>
-          <a:xfrm>
-            <a:off x="731520" y="1600200"/>
-            <a:ext cx="10698480" cy="960120"/>
-          </a:xfrm>
-          <a:prstGeom prst="rect">
-            <a:avLst/>
-          </a:prstGeom>
-          <a:noFill/>
-        </p:spPr>
-        <p:txBody>
-          <a:bodyPr wrap="square">
-            <a:spAutoFit/>
-          </a:bodyPr>
-          <a:lstStyle/>
-          <a:p>
-            <a:pPr algn="l"/>
-            <a:r>
-              <a:rPr sz="1700" b="0">
-                <a:solidFill>
-                  <a:srgbClr val="FFFFFF"/>
-                </a:solidFill>
-              </a:rPr>
-              <a:t>  Every MCP SDK — the Python mcp package, the TypeScript @modelcontextprotocol/sdk, the Rust crate — is an abstraction layer over the same wir</a:t>
-            </a:r>
-          </a:p>
-        </p:txBody>
-      </p:sp>
-      <p:sp>
-        <p:nvSpPr>
-          <p:cNvPr id="5" name="TextBox 4"/>
-          <p:cNvSpPr txBox="1"/>
-          <p:nvPr/>
-        </p:nvSpPr>
-        <p:spPr>
-          <a:xfrm>
-            <a:off x="731520" y="2651760"/>
-            <a:ext cx="10698480" cy="960120"/>
-          </a:xfrm>
-          <a:prstGeom prst="rect">
-            <a:avLst/>
-          </a:prstGeom>
-          <a:noFill/>
-        </p:spPr>
-        <p:txBody>
-          <a:bodyPr wrap="square">
-            <a:spAutoFit/>
-          </a:bodyPr>
-          <a:lstStyle/>
-          <a:p>
-            <a:pPr algn="l"/>
-            <a:r>
-              <a:rPr sz="1700" b="0">
-                <a:solidFill>
-                  <a:srgbClr val="FFFFFF"/>
-                </a:solidFill>
-              </a:rPr>
-              <a:t>  More importantly: once you understand the wire format, the SDK stops being magic. Every SDK call maps to one or two JSON messages. Once you </a:t>
-            </a:r>
-          </a:p>
-        </p:txBody>
-      </p:sp>
-      <p:sp>
-        <p:nvSpPr>
-          <p:cNvPr id="6" name="TextBox 5"/>
-          <p:cNvSpPr txBox="1"/>
-          <p:nvPr/>
-        </p:nvSpPr>
-        <p:spPr>
-          <a:xfrm>
-            <a:off x="731520" y="3703320"/>
-            <a:ext cx="10698480" cy="960120"/>
-          </a:xfrm>
-          <a:prstGeom prst="rect">
-            <a:avLst/>
-          </a:prstGeom>
-          <a:noFill/>
-        </p:spPr>
-        <p:txBody>
-          <a:bodyPr wrap="square">
-            <a:spAutoFit/>
-          </a:bodyPr>
-          <a:lstStyle/>
-          <a:p>
-            <a:pPr algn="l"/>
-            <a:r>
-              <a:rPr sz="1700" b="0">
-                <a:solidFill>
-                  <a:srgbClr val="FFFFFF"/>
-                </a:solidFill>
-              </a:rPr>
-              <a:t>  This chapter builds that fluency from scratch.</a:t>
-            </a:r>
-          </a:p>
-        </p:txBody>
-      </p:sp>
-      <p:sp>
-        <p:nvSpPr>
-          <p:cNvPr id="7" name="TextBox 6"/>
-          <p:cNvSpPr txBox="1"/>
-          <p:nvPr/>
-        </p:nvSpPr>
-        <p:spPr>
-          <a:xfrm>
-            <a:off x="731520" y="6263640"/>
-            <a:ext cx="10698480" cy="365760"/>
-          </a:xfrm>
-          <a:prstGeom prst="rect">
-            <a:avLst/>
-          </a:prstGeom>
-          <a:noFill/>
-        </p:spPr>
-        <p:txBody>
-          <a:bodyPr wrap="square">
-            <a:spAutoFit/>
-          </a:bodyPr>
-          <a:lstStyle/>
-          <a:p>
-            <a:pPr algn="l"/>
-            <a:r>
-              <a:rPr sz="1000" b="0">
-                <a:solidFill>
-                  <a:srgbClr val="A1A1AA"/>
-                </a:solidFill>
-              </a:rPr>
-              <a:t>academy.kspl.tech | Koenig AI Academy</a:t>
-            </a:r>
-          </a:p>
-        </p:txBody>
-      </p:sp>
-    </p:spTree>
-  </p:cSld>
-  <p:clrMapOvr>
-    <a:masterClrMapping/>
-  </p:clrMapOvr>
-</p:sld>
-</file>
-
-<file path=ppt/slides/slide3.xml><?xml version="1.0" encoding="utf-8"?>
-<p:sld xmlns:a="http://schemas.openxmlformats.org/drawingml/2006/main" xmlns:p="http://schemas.openxmlformats.org/presentationml/2006/main" xmlns:r="http://schemas.openxmlformats.org/officeDocument/2006/relationships">
-  <p:cSld>
-    <p:bg>
-      <p:bgPr>
-        <a:solidFill>
-          <a:srgbClr val="18181B"/>
-        </a:solidFill>
-        <a:effectLst/>
-      </p:bgPr>
-    </p:bg>
-    <p:spTree>
-      <p:nvGrpSpPr>
-        <p:cNvPr id="1" name=""/>
-        <p:cNvGrpSpPr/>
-        <p:nvPr/>
-      </p:nvGrpSpPr>
-      <p:grpSpPr/>
-      <p:sp>
-        <p:nvSpPr>
-          <p:cNvPr id="2" name="TextBox 1"/>
-          <p:cNvSpPr txBox="1"/>
-          <p:nvPr/>
-        </p:nvSpPr>
-        <p:spPr>
-          <a:xfrm>
-            <a:off x="731520" y="411480"/>
-            <a:ext cx="10698480" cy="1005840"/>
-          </a:xfrm>
-          <a:prstGeom prst="rect">
-            <a:avLst/>
-          </a:prstGeom>
-          <a:noFill/>
-        </p:spPr>
-        <p:txBody>
-          <a:bodyPr wrap="square">
-            <a:spAutoFit/>
-          </a:bodyPr>
-          <a:lstStyle/>
-          <a:p>
-            <a:pPr algn="l"/>
-            <a:r>
-              <a:rPr sz="2800" b="1">
-                <a:solidFill>
-                  <a:srgbClr val="FFFFFF"/>
-                </a:solidFill>
-              </a:rPr>
-              <a:t>JSON-RPC 2.0: the message envelope</a:t>
-            </a:r>
-          </a:p>
-        </p:txBody>
-      </p:sp>
-      <p:sp>
-        <p:nvSpPr>
           <p:cNvPr id="3" name="Rectangle 2"/>
           <p:cNvSpPr/>
           <p:nvPr/>
         </p:nvSpPr>
         <p:spPr>
           <a:xfrm>
-            <a:off x="731520" y="1417320"/>
-            <a:ext cx="10698480" cy="36576"/>
+            <a:off x="0" y="0"/>
+            <a:ext cx="12191695" cy="54864"/>
           </a:xfrm>
           <a:prstGeom prst="rect">
             <a:avLst/>
           </a:prstGeom>
           <a:solidFill>
-            <a:srgbClr val="A1A1AA"/>
+            <a:srgbClr val="6366F1"/>
           </a:solidFill>
           <a:ln>
             <a:noFill/>
@@ -3520,8 +3188,8 @@
         </p:nvSpPr>
         <p:spPr>
           <a:xfrm>
-            <a:off x="731520" y="1600200"/>
-            <a:ext cx="10698480" cy="960120"/>
+            <a:off x="914400" y="1645920"/>
+            <a:ext cx="10332720" cy="457200"/>
           </a:xfrm>
           <a:prstGeom prst="rect">
             <a:avLst/>
@@ -3534,14 +3202,14 @@
           </a:bodyPr>
           <a:lstStyle/>
           <a:p>
-            <a:pPr algn="l"/>
-            <a:r>
-              <a:rPr sz="1700" b="0">
-                <a:solidFill>
-                  <a:srgbClr val="FFFFFF"/>
+            <a:pPr algn="ctr"/>
+            <a:r>
+              <a:rPr sz="1600" b="1">
+                <a:solidFill>
+                  <a:srgbClr val="A1A1AA"/>
                 </a:solidFill>
               </a:rPr>
-              <a:t>  MCP uses [[JSON-RPC 2.0]][^1] as its message format. This is not an implementation detail — it's a deliberate choice with specific consequen</a:t>
+              <a:t>CHAPTER 2</a:t>
             </a:r>
           </a:p>
         </p:txBody>
@@ -3554,8 +3222,8 @@
         </p:nvSpPr>
         <p:spPr>
           <a:xfrm>
-            <a:off x="731520" y="2651760"/>
-            <a:ext cx="10698480" cy="960120"/>
+            <a:off x="914400" y="2194560"/>
+            <a:ext cx="10332720" cy="1828800"/>
           </a:xfrm>
           <a:prstGeom prst="rect">
             <a:avLst/>
@@ -3568,14 +3236,15 @@
           </a:bodyPr>
           <a:lstStyle/>
           <a:p>
-            <a:pPr algn="l"/>
-            <a:r>
-              <a:rPr sz="1700" b="0">
+            <a:pPr algn="ctr"/>
+            <a:r>
+              <a:rPr sz="3600" b="1">
                 <a:solidFill>
                   <a:srgbClr val="FFFFFF"/>
                 </a:solidFill>
               </a:rPr>
-              <a:t>  JSON-RPC 2.0 defines four message shapes:</a:t>
+              <a:t>JSON-RPC over stdio
+— the wire protocol explained</a:t>
             </a:r>
           </a:p>
         </p:txBody>
@@ -3588,8 +3257,8 @@
         </p:nvSpPr>
         <p:spPr>
           <a:xfrm>
-            <a:off x="731520" y="3703320"/>
-            <a:ext cx="10698480" cy="960120"/>
+            <a:off x="914400" y="4572000"/>
+            <a:ext cx="10332720" cy="457200"/>
           </a:xfrm>
           <a:prstGeom prst="rect">
             <a:avLst/>
@@ -3602,14 +3271,14 @@
           </a:bodyPr>
           <a:lstStyle/>
           <a:p>
-            <a:pPr algn="l"/>
-            <a:r>
-              <a:rPr sz="1700" b="0">
-                <a:solidFill>
-                  <a:srgbClr val="FFFFFF"/>
+            <a:pPr algn="ctr"/>
+            <a:r>
+              <a:rPr sz="1400" b="0">
+                <a:solidFill>
+                  <a:srgbClr val="A1A1AA"/>
                 </a:solidFill>
               </a:rPr>
-              <a:t>  Request (client → server, or server → client)</a:t>
+              <a:t>MCP: From First Principles to Production — Koenig AI Academy</a:t>
             </a:r>
           </a:p>
         </p:txBody>
@@ -3622,42 +3291,8 @@
         </p:nvSpPr>
         <p:spPr>
           <a:xfrm>
-            <a:off x="731520" y="4754880"/>
-            <a:ext cx="10698480" cy="960120"/>
-          </a:xfrm>
-          <a:prstGeom prst="rect">
-            <a:avLst/>
-          </a:prstGeom>
-          <a:noFill/>
-        </p:spPr>
-        <p:txBody>
-          <a:bodyPr wrap="square">
-            <a:spAutoFit/>
-          </a:bodyPr>
-          <a:lstStyle/>
-          <a:p>
-            <a:pPr algn="l"/>
-            <a:r>
-              <a:rPr sz="1700" b="0">
-                <a:solidFill>
-                  <a:srgbClr val="FFFFFF"/>
-                </a:solidFill>
-              </a:rPr>
-              <a:t>  "jsonrpc": "2.0",</a:t>
-            </a:r>
-          </a:p>
-        </p:txBody>
-      </p:sp>
-      <p:sp>
-        <p:nvSpPr>
-          <p:cNvPr id="8" name="TextBox 7"/>
-          <p:cNvSpPr txBox="1"/>
-          <p:nvPr/>
-        </p:nvSpPr>
-        <p:spPr>
-          <a:xfrm>
-            <a:off x="731520" y="6263640"/>
-            <a:ext cx="10698480" cy="365760"/>
+            <a:off x="457200" y="6492240"/>
+            <a:ext cx="11247120" cy="320040"/>
           </a:xfrm>
           <a:prstGeom prst="rect">
             <a:avLst/>
@@ -3690,17 +3325,9 @@
 </p:sld>
 </file>
 
-<file path=ppt/slides/slide4.xml><?xml version="1.0" encoding="utf-8"?>
+<file path=ppt/slides/slide2.xml><?xml version="1.0" encoding="utf-8"?>
 <p:sld xmlns:a="http://schemas.openxmlformats.org/drawingml/2006/main" xmlns:p="http://schemas.openxmlformats.org/presentationml/2006/main" xmlns:r="http://schemas.openxmlformats.org/officeDocument/2006/relationships">
   <p:cSld>
-    <p:bg>
-      <p:bgPr>
-        <a:solidFill>
-          <a:srgbClr val="18181B"/>
-        </a:solidFill>
-        <a:effectLst/>
-      </p:bgPr>
-    </p:bg>
     <p:spTree>
       <p:nvGrpSpPr>
         <p:cNvPr id="1" name=""/>
@@ -3710,54 +3337,20 @@
       <p:grpSpPr/>
       <p:sp>
         <p:nvSpPr>
-          <p:cNvPr id="2" name="TextBox 1"/>
-          <p:cNvSpPr txBox="1"/>
-          <p:nvPr/>
-        </p:nvSpPr>
-        <p:spPr>
-          <a:xfrm>
-            <a:off x="731520" y="411480"/>
-            <a:ext cx="10698480" cy="1005840"/>
-          </a:xfrm>
-          <a:prstGeom prst="rect">
-            <a:avLst/>
-          </a:prstGeom>
-          <a:noFill/>
-        </p:spPr>
-        <p:txBody>
-          <a:bodyPr wrap="square">
-            <a:spAutoFit/>
-          </a:bodyPr>
-          <a:lstStyle/>
-          <a:p>
-            <a:pPr algn="l"/>
-            <a:r>
-              <a:rPr sz="2800" b="1">
-                <a:solidFill>
-                  <a:srgbClr val="FFFFFF"/>
-                </a:solidFill>
-              </a:rPr>
-              <a:t>The stdio transport: why a pipe beats a socket</a:t>
-            </a:r>
-          </a:p>
-        </p:txBody>
-      </p:sp>
-      <p:sp>
-        <p:nvSpPr>
-          <p:cNvPr id="3" name="Rectangle 2"/>
+          <p:cNvPr id="2" name="Rectangle 1"/>
           <p:cNvSpPr/>
           <p:nvPr/>
         </p:nvSpPr>
         <p:spPr>
           <a:xfrm>
-            <a:off x="731520" y="1417320"/>
-            <a:ext cx="10698480" cy="36576"/>
+            <a:off x="0" y="0"/>
+            <a:ext cx="12191695" cy="6858000"/>
           </a:xfrm>
           <a:prstGeom prst="rect">
             <a:avLst/>
           </a:prstGeom>
           <a:solidFill>
-            <a:srgbClr val="A1A1AA"/>
+            <a:srgbClr val="18181B"/>
           </a:solidFill>
           <a:ln>
             <a:noFill/>
@@ -3787,250 +3380,20 @@
       </p:sp>
       <p:sp>
         <p:nvSpPr>
-          <p:cNvPr id="4" name="TextBox 3"/>
-          <p:cNvSpPr txBox="1"/>
-          <p:nvPr/>
-        </p:nvSpPr>
-        <p:spPr>
-          <a:xfrm>
-            <a:off x="731520" y="1600200"/>
-            <a:ext cx="10698480" cy="960120"/>
-          </a:xfrm>
-          <a:prstGeom prst="rect">
-            <a:avLst/>
-          </a:prstGeom>
-          <a:noFill/>
-        </p:spPr>
-        <p:txBody>
-          <a:bodyPr wrap="square">
-            <a:spAutoFit/>
-          </a:bodyPr>
-          <a:lstStyle/>
-          <a:p>
-            <a:pPr algn="l"/>
-            <a:r>
-              <a:rPr sz="1700" b="0">
-                <a:solidFill>
-                  <a:srgbClr val="FFFFFF"/>
-                </a:solidFill>
-              </a:rPr>
-              <a:t>  The technical choice</a:t>
-            </a:r>
-          </a:p>
-        </p:txBody>
-      </p:sp>
-      <p:sp>
-        <p:nvSpPr>
-          <p:cNvPr id="5" name="TextBox 4"/>
-          <p:cNvSpPr txBox="1"/>
-          <p:nvPr/>
-        </p:nvSpPr>
-        <p:spPr>
-          <a:xfrm>
-            <a:off x="731520" y="2651760"/>
-            <a:ext cx="10698480" cy="960120"/>
-          </a:xfrm>
-          <a:prstGeom prst="rect">
-            <a:avLst/>
-          </a:prstGeom>
-          <a:noFill/>
-        </p:spPr>
-        <p:txBody>
-          <a:bodyPr wrap="square">
-            <a:spAutoFit/>
-          </a:bodyPr>
-          <a:lstStyle/>
-          <a:p>
-            <a:pPr algn="l"/>
-            <a:r>
-              <a:rPr sz="1700" b="0">
-                <a:solidFill>
-                  <a:srgbClr val="FFFFFF"/>
-                </a:solidFill>
-              </a:rPr>
-              <a:t>  For local MCP servers — servers running on the same machine as the host — the MCP spec defines [[MCP stdio transport|stdio transport]]: the </a:t>
-            </a:r>
-          </a:p>
-        </p:txBody>
-      </p:sp>
-      <p:sp>
-        <p:nvSpPr>
-          <p:cNvPr id="6" name="TextBox 5"/>
-          <p:cNvSpPr txBox="1"/>
-          <p:nvPr/>
-        </p:nvSpPr>
-        <p:spPr>
-          <a:xfrm>
-            <a:off x="731520" y="3703320"/>
-            <a:ext cx="10698480" cy="960120"/>
-          </a:xfrm>
-          <a:prstGeom prst="rect">
-            <a:avLst/>
-          </a:prstGeom>
-          <a:noFill/>
-        </p:spPr>
-        <p:txBody>
-          <a:bodyPr wrap="square">
-            <a:spAutoFit/>
-          </a:bodyPr>
-          <a:lstStyle/>
-          <a:p>
-            <a:pPr algn="l"/>
-            <a:r>
-              <a:rPr sz="1700" b="0">
-                <a:solidFill>
-                  <a:srgbClr val="FFFFFF"/>
-                </a:solidFill>
-              </a:rPr>
-              <a:t>  This is newline-delimited JSON, also called NDJSON or JSON Lines. The framing rule is brutally simple: read until \n, parse what you got as </a:t>
-            </a:r>
-          </a:p>
-        </p:txBody>
-      </p:sp>
-      <p:sp>
-        <p:nvSpPr>
-          <p:cNvPr id="7" name="TextBox 6"/>
-          <p:cNvSpPr txBox="1"/>
-          <p:nvPr/>
-        </p:nvSpPr>
-        <p:spPr>
-          <a:xfrm>
-            <a:off x="731520" y="4754880"/>
-            <a:ext cx="10698480" cy="960120"/>
-          </a:xfrm>
-          <a:prstGeom prst="rect">
-            <a:avLst/>
-          </a:prstGeom>
-          <a:noFill/>
-        </p:spPr>
-        <p:txBody>
-          <a:bodyPr wrap="square">
-            <a:spAutoFit/>
-          </a:bodyPr>
-          <a:lstStyle/>
-          <a:p>
-            <a:pPr algn="l"/>
-            <a:r>
-              <a:rPr sz="1700" b="0">
-                <a:solidFill>
-                  <a:srgbClr val="FFFFFF"/>
-                </a:solidFill>
-              </a:rPr>
-              <a:t>  [host writes to server stdin]</a:t>
-            </a:r>
-          </a:p>
-        </p:txBody>
-      </p:sp>
-      <p:sp>
-        <p:nvSpPr>
-          <p:cNvPr id="8" name="TextBox 7"/>
-          <p:cNvSpPr txBox="1"/>
-          <p:nvPr/>
-        </p:nvSpPr>
-        <p:spPr>
-          <a:xfrm>
-            <a:off x="731520" y="6263640"/>
-            <a:ext cx="10698480" cy="365760"/>
-          </a:xfrm>
-          <a:prstGeom prst="rect">
-            <a:avLst/>
-          </a:prstGeom>
-          <a:noFill/>
-        </p:spPr>
-        <p:txBody>
-          <a:bodyPr wrap="square">
-            <a:spAutoFit/>
-          </a:bodyPr>
-          <a:lstStyle/>
-          <a:p>
-            <a:pPr algn="l"/>
-            <a:r>
-              <a:rPr sz="1000" b="0">
-                <a:solidFill>
-                  <a:srgbClr val="A1A1AA"/>
-                </a:solidFill>
-              </a:rPr>
-              <a:t>academy.kspl.tech | Koenig AI Academy</a:t>
-            </a:r>
-          </a:p>
-        </p:txBody>
-      </p:sp>
-    </p:spTree>
-  </p:cSld>
-  <p:clrMapOvr>
-    <a:masterClrMapping/>
-  </p:clrMapOvr>
-</p:sld>
-</file>
-
-<file path=ppt/slides/slide5.xml><?xml version="1.0" encoding="utf-8"?>
-<p:sld xmlns:a="http://schemas.openxmlformats.org/drawingml/2006/main" xmlns:p="http://schemas.openxmlformats.org/presentationml/2006/main" xmlns:r="http://schemas.openxmlformats.org/officeDocument/2006/relationships">
-  <p:cSld>
-    <p:bg>
-      <p:bgPr>
-        <a:solidFill>
-          <a:srgbClr val="18181B"/>
-        </a:solidFill>
-        <a:effectLst/>
-      </p:bgPr>
-    </p:bg>
-    <p:spTree>
-      <p:nvGrpSpPr>
-        <p:cNvPr id="1" name=""/>
-        <p:cNvGrpSpPr/>
-        <p:nvPr/>
-      </p:nvGrpSpPr>
-      <p:grpSpPr/>
-      <p:sp>
-        <p:nvSpPr>
-          <p:cNvPr id="2" name="TextBox 1"/>
-          <p:cNvSpPr txBox="1"/>
-          <p:nvPr/>
-        </p:nvSpPr>
-        <p:spPr>
-          <a:xfrm>
-            <a:off x="731520" y="411480"/>
-            <a:ext cx="10698480" cy="1005840"/>
-          </a:xfrm>
-          <a:prstGeom prst="rect">
-            <a:avLst/>
-          </a:prstGeom>
-          <a:noFill/>
-        </p:spPr>
-        <p:txBody>
-          <a:bodyPr wrap="square">
-            <a:spAutoFit/>
-          </a:bodyPr>
-          <a:lstStyle/>
-          <a:p>
-            <a:pPr algn="l"/>
-            <a:r>
-              <a:rPr sz="2800" b="1">
-                <a:solidFill>
-                  <a:srgbClr val="FFFFFF"/>
-                </a:solidFill>
-              </a:rPr>
-              <a:t>The initialize handshake: step by step</a:t>
-            </a:r>
-          </a:p>
-        </p:txBody>
-      </p:sp>
-      <p:sp>
-        <p:nvSpPr>
           <p:cNvPr id="3" name="Rectangle 2"/>
           <p:cNvSpPr/>
           <p:nvPr/>
         </p:nvSpPr>
         <p:spPr>
           <a:xfrm>
-            <a:off x="731520" y="1417320"/>
-            <a:ext cx="10698480" cy="36576"/>
+            <a:off x="0" y="0"/>
+            <a:ext cx="12191695" cy="54864"/>
           </a:xfrm>
           <a:prstGeom prst="rect">
             <a:avLst/>
           </a:prstGeom>
           <a:solidFill>
-            <a:srgbClr val="A1A1AA"/>
+            <a:srgbClr val="6366F1"/>
           </a:solidFill>
           <a:ln>
             <a:noFill/>
@@ -4066,8 +3429,8 @@
         </p:nvSpPr>
         <p:spPr>
           <a:xfrm>
-            <a:off x="731520" y="1600200"/>
-            <a:ext cx="10698480" cy="960120"/>
+            <a:off x="457200" y="164592"/>
+            <a:ext cx="11247120" cy="868680"/>
           </a:xfrm>
           <a:prstGeom prst="rect">
             <a:avLst/>
@@ -4082,222 +3445,26 @@
           <a:p>
             <a:pPr algn="l"/>
             <a:r>
-              <a:rPr sz="1700" b="0">
+              <a:rPr sz="2800" b="1">
                 <a:solidFill>
                   <a:srgbClr val="FFFFFF"/>
                 </a:solidFill>
               </a:rPr>
-              <a:t>  Every MCP session begins with a [[MCP initialize handshake|three-message handshake]][^4]. Understanding it prevents a surprising class of bu</a:t>
-            </a:r>
-          </a:p>
-        </p:txBody>
-      </p:sp>
-      <p:sp>
-        <p:nvSpPr>
-          <p:cNvPr id="5" name="TextBox 4"/>
-          <p:cNvSpPr txBox="1"/>
-          <p:nvPr/>
-        </p:nvSpPr>
-        <p:spPr>
-          <a:xfrm>
-            <a:off x="731520" y="2651760"/>
-            <a:ext cx="10698480" cy="960120"/>
-          </a:xfrm>
-          <a:prstGeom prst="rect">
-            <a:avLst/>
-          </a:prstGeom>
-          <a:noFill/>
-        </p:spPr>
-        <p:txBody>
-          <a:bodyPr wrap="square">
-            <a:spAutoFit/>
-          </a:bodyPr>
-          <a:lstStyle/>
-          <a:p>
-            <a:pPr algn="l"/>
-            <a:r>
-              <a:rPr sz="1700" b="0">
-                <a:solidFill>
-                  <a:srgbClr val="FFFFFF"/>
-                </a:solidFill>
-              </a:rPr>
-              <a:t>  Message 1: `initialize` (client → server)</a:t>
-            </a:r>
-          </a:p>
-        </p:txBody>
-      </p:sp>
-      <p:sp>
-        <p:nvSpPr>
-          <p:cNvPr id="6" name="TextBox 5"/>
-          <p:cNvSpPr txBox="1"/>
-          <p:nvPr/>
-        </p:nvSpPr>
-        <p:spPr>
-          <a:xfrm>
-            <a:off x="731520" y="3703320"/>
-            <a:ext cx="10698480" cy="960120"/>
-          </a:xfrm>
-          <a:prstGeom prst="rect">
-            <a:avLst/>
-          </a:prstGeom>
-          <a:noFill/>
-        </p:spPr>
-        <p:txBody>
-          <a:bodyPr wrap="square">
-            <a:spAutoFit/>
-          </a:bodyPr>
-          <a:lstStyle/>
-          <a:p>
-            <a:pPr algn="l"/>
-            <a:r>
-              <a:rPr sz="1700" b="0">
-                <a:solidFill>
-                  <a:srgbClr val="FFFFFF"/>
-                </a:solidFill>
-              </a:rPr>
-              <a:t>  "jsonrpc": "2.0",</a:t>
-            </a:r>
-          </a:p>
-        </p:txBody>
-      </p:sp>
-      <p:sp>
-        <p:nvSpPr>
-          <p:cNvPr id="7" name="TextBox 6"/>
-          <p:cNvSpPr txBox="1"/>
-          <p:nvPr/>
-        </p:nvSpPr>
-        <p:spPr>
-          <a:xfrm>
-            <a:off x="731520" y="4754880"/>
-            <a:ext cx="10698480" cy="960120"/>
-          </a:xfrm>
-          <a:prstGeom prst="rect">
-            <a:avLst/>
-          </a:prstGeom>
-          <a:noFill/>
-        </p:spPr>
-        <p:txBody>
-          <a:bodyPr wrap="square">
-            <a:spAutoFit/>
-          </a:bodyPr>
-          <a:lstStyle/>
-          <a:p>
-            <a:pPr algn="l"/>
-            <a:r>
-              <a:rPr sz="1700" b="0">
-                <a:solidFill>
-                  <a:srgbClr val="FFFFFF"/>
-                </a:solidFill>
-              </a:rPr>
-              <a:t>  "method": "initialize",</a:t>
-            </a:r>
-          </a:p>
-        </p:txBody>
-      </p:sp>
-      <p:sp>
-        <p:nvSpPr>
-          <p:cNvPr id="8" name="TextBox 7"/>
-          <p:cNvSpPr txBox="1"/>
-          <p:nvPr/>
-        </p:nvSpPr>
-        <p:spPr>
-          <a:xfrm>
-            <a:off x="731520" y="6263640"/>
-            <a:ext cx="10698480" cy="365760"/>
-          </a:xfrm>
-          <a:prstGeom prst="rect">
-            <a:avLst/>
-          </a:prstGeom>
-          <a:noFill/>
-        </p:spPr>
-        <p:txBody>
-          <a:bodyPr wrap="square">
-            <a:spAutoFit/>
-          </a:bodyPr>
-          <a:lstStyle/>
-          <a:p>
-            <a:pPr algn="l"/>
-            <a:r>
-              <a:rPr sz="1000" b="0">
-                <a:solidFill>
-                  <a:srgbClr val="A1A1AA"/>
-                </a:solidFill>
-              </a:rPr>
-              <a:t>academy.kspl.tech | Koenig AI Academy</a:t>
-            </a:r>
-          </a:p>
-        </p:txBody>
-      </p:sp>
-    </p:spTree>
-  </p:cSld>
-  <p:clrMapOvr>
-    <a:masterClrMapping/>
-  </p:clrMapOvr>
-</p:sld>
-</file>
-
-<file path=ppt/slides/slide6.xml><?xml version="1.0" encoding="utf-8"?>
-<p:sld xmlns:a="http://schemas.openxmlformats.org/drawingml/2006/main" xmlns:p="http://schemas.openxmlformats.org/presentationml/2006/main" xmlns:r="http://schemas.openxmlformats.org/officeDocument/2006/relationships">
-  <p:cSld>
-    <p:bg>
-      <p:bgPr>
-        <a:solidFill>
-          <a:srgbClr val="18181B"/>
-        </a:solidFill>
-        <a:effectLst/>
-      </p:bgPr>
-    </p:bg>
-    <p:spTree>
-      <p:nvGrpSpPr>
-        <p:cNvPr id="1" name=""/>
-        <p:cNvGrpSpPr/>
-        <p:nvPr/>
-      </p:nvGrpSpPr>
-      <p:grpSpPr/>
-      <p:sp>
-        <p:nvSpPr>
-          <p:cNvPr id="2" name="TextBox 1"/>
-          <p:cNvSpPr txBox="1"/>
-          <p:nvPr/>
-        </p:nvSpPr>
-        <p:spPr>
-          <a:xfrm>
-            <a:off x="731520" y="411480"/>
-            <a:ext cx="10698480" cy="1005840"/>
-          </a:xfrm>
-          <a:prstGeom prst="rect">
-            <a:avLst/>
-          </a:prstGeom>
-          <a:noFill/>
-        </p:spPr>
-        <p:txBody>
-          <a:bodyPr wrap="square">
-            <a:spAutoFit/>
-          </a:bodyPr>
-          <a:lstStyle/>
-          <a:p>
-            <a:pPr algn="l"/>
-            <a:r>
-              <a:rPr sz="2800" b="1">
-                <a:solidFill>
-                  <a:srgbClr val="FFFFFF"/>
-                </a:solidFill>
-              </a:rPr>
-              <a:t>Reading a real MCP exchange</a:t>
-            </a:r>
-          </a:p>
-        </p:txBody>
-      </p:sp>
-      <p:sp>
-        <p:nvSpPr>
-          <p:cNvPr id="3" name="Rectangle 2"/>
+              <a:t>Why the wire format matters</a:t>
+            </a:r>
+          </a:p>
+        </p:txBody>
+      </p:sp>
+      <p:sp>
+        <p:nvSpPr>
+          <p:cNvPr id="5" name="Rectangle 4"/>
           <p:cNvSpPr/>
           <p:nvPr/>
         </p:nvSpPr>
         <p:spPr>
           <a:xfrm>
-            <a:off x="731520" y="1417320"/>
-            <a:ext cx="10698480" cy="36576"/>
+            <a:off x="457200" y="1143000"/>
+            <a:ext cx="11247120" cy="27432"/>
           </a:xfrm>
           <a:prstGeom prst="rect">
             <a:avLst/>
@@ -4333,14 +3500,14 @@
       </p:sp>
       <p:sp>
         <p:nvSpPr>
-          <p:cNvPr id="4" name="TextBox 3"/>
+          <p:cNvPr id="6" name="TextBox 5"/>
           <p:cNvSpPr txBox="1"/>
           <p:nvPr/>
         </p:nvSpPr>
         <p:spPr>
           <a:xfrm>
-            <a:off x="731520" y="1600200"/>
-            <a:ext cx="10698480" cy="960120"/>
+            <a:off x="502920" y="1298448"/>
+            <a:ext cx="11155680" cy="868680"/>
           </a:xfrm>
           <a:prstGeom prst="rect">
             <a:avLst/>
@@ -4360,21 +3527,21 @@
                   <a:srgbClr val="FFFFFF"/>
                 </a:solidFill>
               </a:rPr>
-              <a:t>  Let's trace a complete tool call from wire to result. The scenario: a user in Claude Desktop asks "What are my open GitHub PRs?" and the hos</a:t>
-            </a:r>
-          </a:p>
-        </p:txBody>
-      </p:sp>
-      <p:sp>
-        <p:nvSpPr>
-          <p:cNvPr id="5" name="TextBox 4"/>
+              <a:t>▸  All MCP SDKs abstract over the same wire protocol — production failures reduce to raw JSON</a:t>
+            </a:r>
+          </a:p>
+        </p:txBody>
+      </p:sp>
+      <p:sp>
+        <p:nvSpPr>
+          <p:cNvPr id="7" name="TextBox 6"/>
           <p:cNvSpPr txBox="1"/>
           <p:nvPr/>
         </p:nvSpPr>
         <p:spPr>
           <a:xfrm>
-            <a:off x="731520" y="2651760"/>
-            <a:ext cx="10698480" cy="960120"/>
+            <a:off x="502920" y="2258568"/>
+            <a:ext cx="11155680" cy="868680"/>
           </a:xfrm>
           <a:prstGeom prst="rect">
             <a:avLst/>
@@ -4394,21 +3561,21 @@
                   <a:srgbClr val="FFFFFF"/>
                 </a:solidFill>
               </a:rPr>
-              <a:t>  Step 1: Host discovers available tools.</a:t>
-            </a:r>
-          </a:p>
-        </p:txBody>
-      </p:sp>
-      <p:sp>
-        <p:nvSpPr>
-          <p:cNvPr id="6" name="TextBox 5"/>
+              <a:t>▸  Every SDK call maps to one or two JSON messages; wire fluency exposes round-trip costs</a:t>
+            </a:r>
+          </a:p>
+        </p:txBody>
+      </p:sp>
+      <p:sp>
+        <p:nvSpPr>
+          <p:cNvPr id="8" name="TextBox 7"/>
           <p:cNvSpPr txBox="1"/>
           <p:nvPr/>
         </p:nvSpPr>
         <p:spPr>
           <a:xfrm>
-            <a:off x="731520" y="3703320"/>
-            <a:ext cx="10698480" cy="960120"/>
+            <a:off x="502920" y="3218688"/>
+            <a:ext cx="11155680" cy="868680"/>
           </a:xfrm>
           <a:prstGeom prst="rect">
             <a:avLst/>
@@ -4428,21 +3595,21 @@
                   <a:srgbClr val="FFFFFF"/>
                 </a:solidFill>
               </a:rPr>
-              <a:t>  → {"jsonrpc":"2.0","id":2,"method":"tools/list","params":{}}</a:t>
-            </a:r>
-          </a:p>
-        </p:txBody>
-      </p:sp>
-      <p:sp>
-        <p:nvSpPr>
-          <p:cNvPr id="7" name="TextBox 6"/>
+              <a:t>▸  Wire format knowledge reveals error shapes, security exposure, and protocol invariants</a:t>
+            </a:r>
+          </a:p>
+        </p:txBody>
+      </p:sp>
+      <p:sp>
+        <p:nvSpPr>
+          <p:cNvPr id="9" name="TextBox 8"/>
           <p:cNvSpPr txBox="1"/>
           <p:nvPr/>
         </p:nvSpPr>
         <p:spPr>
           <a:xfrm>
-            <a:off x="731520" y="4754880"/>
-            <a:ext cx="10698480" cy="960120"/>
+            <a:off x="502920" y="4178808"/>
+            <a:ext cx="11155680" cy="868680"/>
           </a:xfrm>
           <a:prstGeom prst="rect">
             <a:avLst/>
@@ -4462,7 +3629,290 @@
                   <a:srgbClr val="FFFFFF"/>
                 </a:solidFill>
               </a:rPr>
-              <a:t>  "jsonrpc":"2.0",</a:t>
+              <a:t>▸  SDK fluency without wire fluency: you can configure MCP integrations but not diagnose them</a:t>
+            </a:r>
+          </a:p>
+        </p:txBody>
+      </p:sp>
+      <p:sp>
+        <p:nvSpPr>
+          <p:cNvPr id="10" name="TextBox 9"/>
+          <p:cNvSpPr txBox="1"/>
+          <p:nvPr/>
+        </p:nvSpPr>
+        <p:spPr>
+          <a:xfrm>
+            <a:off x="457200" y="6492240"/>
+            <a:ext cx="11247120" cy="320040"/>
+          </a:xfrm>
+          <a:prstGeom prst="rect">
+            <a:avLst/>
+          </a:prstGeom>
+          <a:noFill/>
+        </p:spPr>
+        <p:txBody>
+          <a:bodyPr wrap="square">
+            <a:spAutoFit/>
+          </a:bodyPr>
+          <a:lstStyle/>
+          <a:p>
+            <a:pPr algn="l"/>
+            <a:r>
+              <a:rPr sz="1000" b="0">
+                <a:solidFill>
+                  <a:srgbClr val="A1A1AA"/>
+                </a:solidFill>
+              </a:rPr>
+              <a:t>academy.kspl.tech | Koenig AI Academy</a:t>
+            </a:r>
+          </a:p>
+        </p:txBody>
+      </p:sp>
+    </p:spTree>
+  </p:cSld>
+  <p:clrMapOvr>
+    <a:masterClrMapping/>
+  </p:clrMapOvr>
+</p:sld>
+</file>
+
+<file path=ppt/slides/slide3.xml><?xml version="1.0" encoding="utf-8"?>
+<p:sld xmlns:a="http://schemas.openxmlformats.org/drawingml/2006/main" xmlns:p="http://schemas.openxmlformats.org/presentationml/2006/main" xmlns:r="http://schemas.openxmlformats.org/officeDocument/2006/relationships">
+  <p:cSld>
+    <p:spTree>
+      <p:nvGrpSpPr>
+        <p:cNvPr id="1" name=""/>
+        <p:cNvGrpSpPr/>
+        <p:nvPr/>
+      </p:nvGrpSpPr>
+      <p:grpSpPr/>
+      <p:sp>
+        <p:nvSpPr>
+          <p:cNvPr id="2" name="Rectangle 1"/>
+          <p:cNvSpPr/>
+          <p:nvPr/>
+        </p:nvSpPr>
+        <p:spPr>
+          <a:xfrm>
+            <a:off x="0" y="0"/>
+            <a:ext cx="12191695" cy="6858000"/>
+          </a:xfrm>
+          <a:prstGeom prst="rect">
+            <a:avLst/>
+          </a:prstGeom>
+          <a:solidFill>
+            <a:srgbClr val="18181B"/>
+          </a:solidFill>
+          <a:ln>
+            <a:noFill/>
+          </a:ln>
+        </p:spPr>
+        <p:style>
+          <a:lnRef idx="1">
+            <a:schemeClr val="accent1"/>
+          </a:lnRef>
+          <a:fillRef idx="3">
+            <a:schemeClr val="accent1"/>
+          </a:fillRef>
+          <a:effectRef idx="2">
+            <a:schemeClr val="accent1"/>
+          </a:effectRef>
+          <a:fontRef idx="minor">
+            <a:schemeClr val="lt1"/>
+          </a:fontRef>
+        </p:style>
+        <p:txBody>
+          <a:bodyPr rtlCol="0" anchor="ctr"/>
+          <a:lstStyle/>
+          <a:p>
+            <a:pPr algn="ctr"/>
+          </a:p>
+        </p:txBody>
+      </p:sp>
+      <p:sp>
+        <p:nvSpPr>
+          <p:cNvPr id="3" name="Rectangle 2"/>
+          <p:cNvSpPr/>
+          <p:nvPr/>
+        </p:nvSpPr>
+        <p:spPr>
+          <a:xfrm>
+            <a:off x="0" y="0"/>
+            <a:ext cx="12191695" cy="54864"/>
+          </a:xfrm>
+          <a:prstGeom prst="rect">
+            <a:avLst/>
+          </a:prstGeom>
+          <a:solidFill>
+            <a:srgbClr val="6366F1"/>
+          </a:solidFill>
+          <a:ln>
+            <a:noFill/>
+          </a:ln>
+        </p:spPr>
+        <p:style>
+          <a:lnRef idx="1">
+            <a:schemeClr val="accent1"/>
+          </a:lnRef>
+          <a:fillRef idx="3">
+            <a:schemeClr val="accent1"/>
+          </a:fillRef>
+          <a:effectRef idx="2">
+            <a:schemeClr val="accent1"/>
+          </a:effectRef>
+          <a:fontRef idx="minor">
+            <a:schemeClr val="lt1"/>
+          </a:fontRef>
+        </p:style>
+        <p:txBody>
+          <a:bodyPr rtlCol="0" anchor="ctr"/>
+          <a:lstStyle/>
+          <a:p>
+            <a:pPr algn="ctr"/>
+          </a:p>
+        </p:txBody>
+      </p:sp>
+      <p:sp>
+        <p:nvSpPr>
+          <p:cNvPr id="4" name="TextBox 3"/>
+          <p:cNvSpPr txBox="1"/>
+          <p:nvPr/>
+        </p:nvSpPr>
+        <p:spPr>
+          <a:xfrm>
+            <a:off x="457200" y="164592"/>
+            <a:ext cx="11247120" cy="868680"/>
+          </a:xfrm>
+          <a:prstGeom prst="rect">
+            <a:avLst/>
+          </a:prstGeom>
+          <a:noFill/>
+        </p:spPr>
+        <p:txBody>
+          <a:bodyPr wrap="square">
+            <a:spAutoFit/>
+          </a:bodyPr>
+          <a:lstStyle/>
+          <a:p>
+            <a:pPr algn="l"/>
+            <a:r>
+              <a:rPr sz="2800" b="1">
+                <a:solidFill>
+                  <a:srgbClr val="FFFFFF"/>
+                </a:solidFill>
+              </a:rPr>
+              <a:t>JSON-RPC 2.0 — the message envelope</a:t>
+            </a:r>
+          </a:p>
+        </p:txBody>
+      </p:sp>
+      <p:sp>
+        <p:nvSpPr>
+          <p:cNvPr id="5" name="Rectangle 4"/>
+          <p:cNvSpPr/>
+          <p:nvPr/>
+        </p:nvSpPr>
+        <p:spPr>
+          <a:xfrm>
+            <a:off x="457200" y="1143000"/>
+            <a:ext cx="11247120" cy="27432"/>
+          </a:xfrm>
+          <a:prstGeom prst="rect">
+            <a:avLst/>
+          </a:prstGeom>
+          <a:solidFill>
+            <a:srgbClr val="A1A1AA"/>
+          </a:solidFill>
+          <a:ln>
+            <a:noFill/>
+          </a:ln>
+        </p:spPr>
+        <p:style>
+          <a:lnRef idx="1">
+            <a:schemeClr val="accent1"/>
+          </a:lnRef>
+          <a:fillRef idx="3">
+            <a:schemeClr val="accent1"/>
+          </a:fillRef>
+          <a:effectRef idx="2">
+            <a:schemeClr val="accent1"/>
+          </a:effectRef>
+          <a:fontRef idx="minor">
+            <a:schemeClr val="lt1"/>
+          </a:fontRef>
+        </p:style>
+        <p:txBody>
+          <a:bodyPr rtlCol="0" anchor="ctr"/>
+          <a:lstStyle/>
+          <a:p>
+            <a:pPr algn="ctr"/>
+          </a:p>
+        </p:txBody>
+      </p:sp>
+      <p:sp>
+        <p:nvSpPr>
+          <p:cNvPr id="6" name="TextBox 5"/>
+          <p:cNvSpPr txBox="1"/>
+          <p:nvPr/>
+        </p:nvSpPr>
+        <p:spPr>
+          <a:xfrm>
+            <a:off x="502920" y="1298448"/>
+            <a:ext cx="11155680" cy="731520"/>
+          </a:xfrm>
+          <a:prstGeom prst="rect">
+            <a:avLst/>
+          </a:prstGeom>
+          <a:noFill/>
+        </p:spPr>
+        <p:txBody>
+          <a:bodyPr wrap="square">
+            <a:spAutoFit/>
+          </a:bodyPr>
+          <a:lstStyle/>
+          <a:p>
+            <a:pPr algn="l"/>
+            <a:r>
+              <a:rPr sz="1500" b="0">
+                <a:solidFill>
+                  <a:srgbClr val="FFFFFF"/>
+                </a:solidFill>
+              </a:rPr>
+              <a:t>▸  MCP uses JSON-RPC 2.0 as its message format — a deliberate choice, not an implementation detail</a:t>
+            </a:r>
+          </a:p>
+        </p:txBody>
+      </p:sp>
+      <p:sp>
+        <p:nvSpPr>
+          <p:cNvPr id="7" name="TextBox 6"/>
+          <p:cNvSpPr txBox="1"/>
+          <p:nvPr/>
+        </p:nvSpPr>
+        <p:spPr>
+          <a:xfrm>
+            <a:off x="502920" y="2121408"/>
+            <a:ext cx="11155680" cy="731520"/>
+          </a:xfrm>
+          <a:prstGeom prst="rect">
+            <a:avLst/>
+          </a:prstGeom>
+          <a:noFill/>
+        </p:spPr>
+        <p:txBody>
+          <a:bodyPr wrap="square">
+            <a:spAutoFit/>
+          </a:bodyPr>
+          <a:lstStyle/>
+          <a:p>
+            <a:pPr algn="l"/>
+            <a:r>
+              <a:rPr sz="1500" b="0">
+                <a:solidFill>
+                  <a:srgbClr val="FFFFFF"/>
+                </a:solidFill>
+              </a:rPr>
+              <a:t>▸  The id field correlates responses to requests; enables multiple in-flight requests simultaneously</a:t>
             </a:r>
           </a:p>
         </p:txBody>
@@ -4475,8 +3925,1265 @@
         </p:nvSpPr>
         <p:spPr>
           <a:xfrm>
-            <a:off x="731520" y="6263640"/>
-            <a:ext cx="10698480" cy="365760"/>
+            <a:off x="502920" y="2944368"/>
+            <a:ext cx="11155680" cy="731520"/>
+          </a:xfrm>
+          <a:prstGeom prst="rect">
+            <a:avLst/>
+          </a:prstGeom>
+          <a:noFill/>
+        </p:spPr>
+        <p:txBody>
+          <a:bodyPr wrap="square">
+            <a:spAutoFit/>
+          </a:bodyPr>
+          <a:lstStyle/>
+          <a:p>
+            <a:pPr algn="l"/>
+            <a:r>
+              <a:rPr sz="1500" b="0">
+                <a:solidFill>
+                  <a:srgbClr val="FFFFFF"/>
+                </a:solidFill>
+              </a:rPr>
+              <a:t>▸  Notifications have no id field — one-way messages; the sender never expects a response</a:t>
+            </a:r>
+          </a:p>
+        </p:txBody>
+      </p:sp>
+      <p:sp>
+        <p:nvSpPr>
+          <p:cNvPr id="9" name="TextBox 8"/>
+          <p:cNvSpPr txBox="1"/>
+          <p:nvPr/>
+        </p:nvSpPr>
+        <p:spPr>
+          <a:xfrm>
+            <a:off x="502920" y="3767328"/>
+            <a:ext cx="11155680" cy="731520"/>
+          </a:xfrm>
+          <a:prstGeom prst="rect">
+            <a:avLst/>
+          </a:prstGeom>
+          <a:noFill/>
+        </p:spPr>
+        <p:txBody>
+          <a:bodyPr wrap="square">
+            <a:spAutoFit/>
+          </a:bodyPr>
+          <a:lstStyle/>
+          <a:p>
+            <a:pPr algn="l"/>
+            <a:r>
+              <a:rPr sz="1500" b="0">
+                <a:solidFill>
+                  <a:srgbClr val="FFFFFF"/>
+                </a:solidFill>
+              </a:rPr>
+              <a:t>▸  error and result are mutually exclusive in a response — a valid response carries exactly one</a:t>
+            </a:r>
+          </a:p>
+        </p:txBody>
+      </p:sp>
+      <p:sp>
+        <p:nvSpPr>
+          <p:cNvPr id="10" name="TextBox 9"/>
+          <p:cNvSpPr txBox="1"/>
+          <p:nvPr/>
+        </p:nvSpPr>
+        <p:spPr>
+          <a:xfrm>
+            <a:off x="502920" y="4590288"/>
+            <a:ext cx="11155680" cy="731520"/>
+          </a:xfrm>
+          <a:prstGeom prst="rect">
+            <a:avLst/>
+          </a:prstGeom>
+          <a:noFill/>
+        </p:spPr>
+        <p:txBody>
+          <a:bodyPr wrap="square">
+            <a:spAutoFit/>
+          </a:bodyPr>
+          <a:lstStyle/>
+          <a:p>
+            <a:pPr algn="l"/>
+            <a:r>
+              <a:rPr sz="1500" b="0">
+                <a:solidFill>
+                  <a:srgbClr val="FFFFFF"/>
+                </a:solidFill>
+              </a:rPr>
+              <a:t>▸  Spec: https://www.jsonrpc.org/specification</a:t>
+            </a:r>
+          </a:p>
+        </p:txBody>
+      </p:sp>
+      <p:sp>
+        <p:nvSpPr>
+          <p:cNvPr id="11" name="TextBox 10"/>
+          <p:cNvSpPr txBox="1"/>
+          <p:nvPr/>
+        </p:nvSpPr>
+        <p:spPr>
+          <a:xfrm>
+            <a:off x="457200" y="6492240"/>
+            <a:ext cx="11247120" cy="320040"/>
+          </a:xfrm>
+          <a:prstGeom prst="rect">
+            <a:avLst/>
+          </a:prstGeom>
+          <a:noFill/>
+        </p:spPr>
+        <p:txBody>
+          <a:bodyPr wrap="square">
+            <a:spAutoFit/>
+          </a:bodyPr>
+          <a:lstStyle/>
+          <a:p>
+            <a:pPr algn="l"/>
+            <a:r>
+              <a:rPr sz="1000" b="0">
+                <a:solidFill>
+                  <a:srgbClr val="A1A1AA"/>
+                </a:solidFill>
+              </a:rPr>
+              <a:t>academy.kspl.tech | Koenig AI Academy</a:t>
+            </a:r>
+          </a:p>
+        </p:txBody>
+      </p:sp>
+    </p:spTree>
+  </p:cSld>
+  <p:clrMapOvr>
+    <a:masterClrMapping/>
+  </p:clrMapOvr>
+</p:sld>
+</file>
+
+<file path=ppt/slides/slide4.xml><?xml version="1.0" encoding="utf-8"?>
+<p:sld xmlns:a="http://schemas.openxmlformats.org/drawingml/2006/main" xmlns:p="http://schemas.openxmlformats.org/presentationml/2006/main" xmlns:r="http://schemas.openxmlformats.org/officeDocument/2006/relationships">
+  <p:cSld>
+    <p:spTree>
+      <p:nvGrpSpPr>
+        <p:cNvPr id="1" name=""/>
+        <p:cNvGrpSpPr/>
+        <p:nvPr/>
+      </p:nvGrpSpPr>
+      <p:grpSpPr/>
+      <p:sp>
+        <p:nvSpPr>
+          <p:cNvPr id="2" name="Rectangle 1"/>
+          <p:cNvSpPr/>
+          <p:nvPr/>
+        </p:nvSpPr>
+        <p:spPr>
+          <a:xfrm>
+            <a:off x="0" y="0"/>
+            <a:ext cx="12191695" cy="6858000"/>
+          </a:xfrm>
+          <a:prstGeom prst="rect">
+            <a:avLst/>
+          </a:prstGeom>
+          <a:solidFill>
+            <a:srgbClr val="18181B"/>
+          </a:solidFill>
+          <a:ln>
+            <a:noFill/>
+          </a:ln>
+        </p:spPr>
+        <p:style>
+          <a:lnRef idx="1">
+            <a:schemeClr val="accent1"/>
+          </a:lnRef>
+          <a:fillRef idx="3">
+            <a:schemeClr val="accent1"/>
+          </a:fillRef>
+          <a:effectRef idx="2">
+            <a:schemeClr val="accent1"/>
+          </a:effectRef>
+          <a:fontRef idx="minor">
+            <a:schemeClr val="lt1"/>
+          </a:fontRef>
+        </p:style>
+        <p:txBody>
+          <a:bodyPr rtlCol="0" anchor="ctr"/>
+          <a:lstStyle/>
+          <a:p>
+            <a:pPr algn="ctr"/>
+          </a:p>
+        </p:txBody>
+      </p:sp>
+      <p:sp>
+        <p:nvSpPr>
+          <p:cNvPr id="3" name="Rectangle 2"/>
+          <p:cNvSpPr/>
+          <p:nvPr/>
+        </p:nvSpPr>
+        <p:spPr>
+          <a:xfrm>
+            <a:off x="0" y="0"/>
+            <a:ext cx="12191695" cy="54864"/>
+          </a:xfrm>
+          <a:prstGeom prst="rect">
+            <a:avLst/>
+          </a:prstGeom>
+          <a:solidFill>
+            <a:srgbClr val="6366F1"/>
+          </a:solidFill>
+          <a:ln>
+            <a:noFill/>
+          </a:ln>
+        </p:spPr>
+        <p:style>
+          <a:lnRef idx="1">
+            <a:schemeClr val="accent1"/>
+          </a:lnRef>
+          <a:fillRef idx="3">
+            <a:schemeClr val="accent1"/>
+          </a:fillRef>
+          <a:effectRef idx="2">
+            <a:schemeClr val="accent1"/>
+          </a:effectRef>
+          <a:fontRef idx="minor">
+            <a:schemeClr val="lt1"/>
+          </a:fontRef>
+        </p:style>
+        <p:txBody>
+          <a:bodyPr rtlCol="0" anchor="ctr"/>
+          <a:lstStyle/>
+          <a:p>
+            <a:pPr algn="ctr"/>
+          </a:p>
+        </p:txBody>
+      </p:sp>
+      <p:sp>
+        <p:nvSpPr>
+          <p:cNvPr id="4" name="TextBox 3"/>
+          <p:cNvSpPr txBox="1"/>
+          <p:nvPr/>
+        </p:nvSpPr>
+        <p:spPr>
+          <a:xfrm>
+            <a:off x="457200" y="164592"/>
+            <a:ext cx="11247120" cy="868680"/>
+          </a:xfrm>
+          <a:prstGeom prst="rect">
+            <a:avLst/>
+          </a:prstGeom>
+          <a:noFill/>
+        </p:spPr>
+        <p:txBody>
+          <a:bodyPr wrap="square">
+            <a:spAutoFit/>
+          </a:bodyPr>
+          <a:lstStyle/>
+          <a:p>
+            <a:pPr algn="l"/>
+            <a:r>
+              <a:rPr sz="2800" b="1">
+                <a:solidFill>
+                  <a:srgbClr val="FFFFFF"/>
+                </a:solidFill>
+              </a:rPr>
+              <a:t>stdio transport — why a pipe beats a socket</a:t>
+            </a:r>
+          </a:p>
+        </p:txBody>
+      </p:sp>
+      <p:sp>
+        <p:nvSpPr>
+          <p:cNvPr id="5" name="Rectangle 4"/>
+          <p:cNvSpPr/>
+          <p:nvPr/>
+        </p:nvSpPr>
+        <p:spPr>
+          <a:xfrm>
+            <a:off x="457200" y="1143000"/>
+            <a:ext cx="11247120" cy="27432"/>
+          </a:xfrm>
+          <a:prstGeom prst="rect">
+            <a:avLst/>
+          </a:prstGeom>
+          <a:solidFill>
+            <a:srgbClr val="A1A1AA"/>
+          </a:solidFill>
+          <a:ln>
+            <a:noFill/>
+          </a:ln>
+        </p:spPr>
+        <p:style>
+          <a:lnRef idx="1">
+            <a:schemeClr val="accent1"/>
+          </a:lnRef>
+          <a:fillRef idx="3">
+            <a:schemeClr val="accent1"/>
+          </a:fillRef>
+          <a:effectRef idx="2">
+            <a:schemeClr val="accent1"/>
+          </a:effectRef>
+          <a:fontRef idx="minor">
+            <a:schemeClr val="lt1"/>
+          </a:fontRef>
+        </p:style>
+        <p:txBody>
+          <a:bodyPr rtlCol="0" anchor="ctr"/>
+          <a:lstStyle/>
+          <a:p>
+            <a:pPr algn="ctr"/>
+          </a:p>
+        </p:txBody>
+      </p:sp>
+      <p:sp>
+        <p:nvSpPr>
+          <p:cNvPr id="6" name="TextBox 5"/>
+          <p:cNvSpPr txBox="1"/>
+          <p:nvPr/>
+        </p:nvSpPr>
+        <p:spPr>
+          <a:xfrm>
+            <a:off x="502920" y="1298448"/>
+            <a:ext cx="11155680" cy="731520"/>
+          </a:xfrm>
+          <a:prstGeom prst="rect">
+            <a:avLst/>
+          </a:prstGeom>
+          <a:noFill/>
+        </p:spPr>
+        <p:txBody>
+          <a:bodyPr wrap="square">
+            <a:spAutoFit/>
+          </a:bodyPr>
+          <a:lstStyle/>
+          <a:p>
+            <a:pPr algn="l"/>
+            <a:r>
+              <a:rPr sz="1500" b="0">
+                <a:solidFill>
+                  <a:srgbClr val="FFFFFF"/>
+                </a:solidFill>
+              </a:rPr>
+              <a:t>▸  Host launches MCP server as a subprocess; communication is via stdin and stdout pipes</a:t>
+            </a:r>
+          </a:p>
+        </p:txBody>
+      </p:sp>
+      <p:sp>
+        <p:nvSpPr>
+          <p:cNvPr id="7" name="TextBox 6"/>
+          <p:cNvSpPr txBox="1"/>
+          <p:nvPr/>
+        </p:nvSpPr>
+        <p:spPr>
+          <a:xfrm>
+            <a:off x="502920" y="2121408"/>
+            <a:ext cx="11155680" cy="731520"/>
+          </a:xfrm>
+          <a:prstGeom prst="rect">
+            <a:avLst/>
+          </a:prstGeom>
+          <a:noFill/>
+        </p:spPr>
+        <p:txBody>
+          <a:bodyPr wrap="square">
+            <a:spAutoFit/>
+          </a:bodyPr>
+          <a:lstStyle/>
+          <a:p>
+            <a:pPr algn="l"/>
+            <a:r>
+              <a:rPr sz="1500" b="0">
+                <a:solidFill>
+                  <a:srgbClr val="FFFFFF"/>
+                </a:solidFill>
+              </a:rPr>
+              <a:t>▸  Framing rule: read until newline, parse as JSON — no sockets, no ports, no TLS needed</a:t>
+            </a:r>
+          </a:p>
+        </p:txBody>
+      </p:sp>
+      <p:sp>
+        <p:nvSpPr>
+          <p:cNvPr id="8" name="TextBox 7"/>
+          <p:cNvSpPr txBox="1"/>
+          <p:nvPr/>
+        </p:nvSpPr>
+        <p:spPr>
+          <a:xfrm>
+            <a:off x="502920" y="2944368"/>
+            <a:ext cx="11155680" cy="731520"/>
+          </a:xfrm>
+          <a:prstGeom prst="rect">
+            <a:avLst/>
+          </a:prstGeom>
+          <a:noFill/>
+        </p:spPr>
+        <p:txBody>
+          <a:bodyPr wrap="square">
+            <a:spAutoFit/>
+          </a:bodyPr>
+          <a:lstStyle/>
+          <a:p>
+            <a:pPr algn="l"/>
+            <a:r>
+              <a:rPr sz="1500" b="0">
+                <a:solidFill>
+                  <a:srgbClr val="FFFFFF"/>
+                </a:solidFill>
+              </a:rPr>
+              <a:t>▸  Subprocess lifecycle: server dies when host closes the pipe — no cleanup logic required</a:t>
+            </a:r>
+          </a:p>
+        </p:txBody>
+      </p:sp>
+      <p:sp>
+        <p:nvSpPr>
+          <p:cNvPr id="9" name="TextBox 8"/>
+          <p:cNvSpPr txBox="1"/>
+          <p:nvPr/>
+        </p:nvSpPr>
+        <p:spPr>
+          <a:xfrm>
+            <a:off x="502920" y="3767328"/>
+            <a:ext cx="11155680" cy="731520"/>
+          </a:xfrm>
+          <a:prstGeom prst="rect">
+            <a:avLst/>
+          </a:prstGeom>
+          <a:noFill/>
+        </p:spPr>
+        <p:txBody>
+          <a:bodyPr wrap="square">
+            <a:spAutoFit/>
+          </a:bodyPr>
+          <a:lstStyle/>
+          <a:p>
+            <a:pPr algn="l"/>
+            <a:r>
+              <a:rPr sz="1500" b="0">
+                <a:solidFill>
+                  <a:srgbClr val="FFFFFF"/>
+                </a:solidFill>
+              </a:rPr>
+              <a:t>▸  stderr is strictly for logs — any non-JSON text on stdout corrupts the JSON-RPC stream</a:t>
+            </a:r>
+          </a:p>
+        </p:txBody>
+      </p:sp>
+      <p:sp>
+        <p:nvSpPr>
+          <p:cNvPr id="10" name="TextBox 9"/>
+          <p:cNvSpPr txBox="1"/>
+          <p:nvPr/>
+        </p:nvSpPr>
+        <p:spPr>
+          <a:xfrm>
+            <a:off x="502920" y="4590288"/>
+            <a:ext cx="11155680" cy="731520"/>
+          </a:xfrm>
+          <a:prstGeom prst="rect">
+            <a:avLst/>
+          </a:prstGeom>
+          <a:noFill/>
+        </p:spPr>
+        <p:txBody>
+          <a:bodyPr wrap="square">
+            <a:spAutoFit/>
+          </a:bodyPr>
+          <a:lstStyle/>
+          <a:p>
+            <a:pPr algn="l"/>
+            <a:r>
+              <a:rPr sz="1500" b="0">
+                <a:solidFill>
+                  <a:srgbClr val="FFFFFF"/>
+                </a:solidFill>
+              </a:rPr>
+              <a:t>▸  Spec: https://spec.modelcontextprotocol.io/specification/2025-03-26/basic/transports/</a:t>
+            </a:r>
+          </a:p>
+        </p:txBody>
+      </p:sp>
+      <p:sp>
+        <p:nvSpPr>
+          <p:cNvPr id="11" name="TextBox 10"/>
+          <p:cNvSpPr txBox="1"/>
+          <p:nvPr/>
+        </p:nvSpPr>
+        <p:spPr>
+          <a:xfrm>
+            <a:off x="457200" y="6492240"/>
+            <a:ext cx="11247120" cy="320040"/>
+          </a:xfrm>
+          <a:prstGeom prst="rect">
+            <a:avLst/>
+          </a:prstGeom>
+          <a:noFill/>
+        </p:spPr>
+        <p:txBody>
+          <a:bodyPr wrap="square">
+            <a:spAutoFit/>
+          </a:bodyPr>
+          <a:lstStyle/>
+          <a:p>
+            <a:pPr algn="l"/>
+            <a:r>
+              <a:rPr sz="1000" b="0">
+                <a:solidFill>
+                  <a:srgbClr val="A1A1AA"/>
+                </a:solidFill>
+              </a:rPr>
+              <a:t>academy.kspl.tech | Koenig AI Academy</a:t>
+            </a:r>
+          </a:p>
+        </p:txBody>
+      </p:sp>
+    </p:spTree>
+  </p:cSld>
+  <p:clrMapOvr>
+    <a:masterClrMapping/>
+  </p:clrMapOvr>
+</p:sld>
+</file>
+
+<file path=ppt/slides/slide5.xml><?xml version="1.0" encoding="utf-8"?>
+<p:sld xmlns:a="http://schemas.openxmlformats.org/drawingml/2006/main" xmlns:p="http://schemas.openxmlformats.org/presentationml/2006/main" xmlns:r="http://schemas.openxmlformats.org/officeDocument/2006/relationships">
+  <p:cSld>
+    <p:spTree>
+      <p:nvGrpSpPr>
+        <p:cNvPr id="1" name=""/>
+        <p:cNvGrpSpPr/>
+        <p:nvPr/>
+      </p:nvGrpSpPr>
+      <p:grpSpPr/>
+      <p:sp>
+        <p:nvSpPr>
+          <p:cNvPr id="2" name="Rectangle 1"/>
+          <p:cNvSpPr/>
+          <p:nvPr/>
+        </p:nvSpPr>
+        <p:spPr>
+          <a:xfrm>
+            <a:off x="0" y="0"/>
+            <a:ext cx="12191695" cy="6858000"/>
+          </a:xfrm>
+          <a:prstGeom prst="rect">
+            <a:avLst/>
+          </a:prstGeom>
+          <a:solidFill>
+            <a:srgbClr val="18181B"/>
+          </a:solidFill>
+          <a:ln>
+            <a:noFill/>
+          </a:ln>
+        </p:spPr>
+        <p:style>
+          <a:lnRef idx="1">
+            <a:schemeClr val="accent1"/>
+          </a:lnRef>
+          <a:fillRef idx="3">
+            <a:schemeClr val="accent1"/>
+          </a:fillRef>
+          <a:effectRef idx="2">
+            <a:schemeClr val="accent1"/>
+          </a:effectRef>
+          <a:fontRef idx="minor">
+            <a:schemeClr val="lt1"/>
+          </a:fontRef>
+        </p:style>
+        <p:txBody>
+          <a:bodyPr rtlCol="0" anchor="ctr"/>
+          <a:lstStyle/>
+          <a:p>
+            <a:pPr algn="ctr"/>
+          </a:p>
+        </p:txBody>
+      </p:sp>
+      <p:sp>
+        <p:nvSpPr>
+          <p:cNvPr id="3" name="Rectangle 2"/>
+          <p:cNvSpPr/>
+          <p:nvPr/>
+        </p:nvSpPr>
+        <p:spPr>
+          <a:xfrm>
+            <a:off x="0" y="0"/>
+            <a:ext cx="12191695" cy="54864"/>
+          </a:xfrm>
+          <a:prstGeom prst="rect">
+            <a:avLst/>
+          </a:prstGeom>
+          <a:solidFill>
+            <a:srgbClr val="6366F1"/>
+          </a:solidFill>
+          <a:ln>
+            <a:noFill/>
+          </a:ln>
+        </p:spPr>
+        <p:style>
+          <a:lnRef idx="1">
+            <a:schemeClr val="accent1"/>
+          </a:lnRef>
+          <a:fillRef idx="3">
+            <a:schemeClr val="accent1"/>
+          </a:fillRef>
+          <a:effectRef idx="2">
+            <a:schemeClr val="accent1"/>
+          </a:effectRef>
+          <a:fontRef idx="minor">
+            <a:schemeClr val="lt1"/>
+          </a:fontRef>
+        </p:style>
+        <p:txBody>
+          <a:bodyPr rtlCol="0" anchor="ctr"/>
+          <a:lstStyle/>
+          <a:p>
+            <a:pPr algn="ctr"/>
+          </a:p>
+        </p:txBody>
+      </p:sp>
+      <p:sp>
+        <p:nvSpPr>
+          <p:cNvPr id="4" name="TextBox 3"/>
+          <p:cNvSpPr txBox="1"/>
+          <p:nvPr/>
+        </p:nvSpPr>
+        <p:spPr>
+          <a:xfrm>
+            <a:off x="457200" y="164592"/>
+            <a:ext cx="11247120" cy="868680"/>
+          </a:xfrm>
+          <a:prstGeom prst="rect">
+            <a:avLst/>
+          </a:prstGeom>
+          <a:noFill/>
+        </p:spPr>
+        <p:txBody>
+          <a:bodyPr wrap="square">
+            <a:spAutoFit/>
+          </a:bodyPr>
+          <a:lstStyle/>
+          <a:p>
+            <a:pPr algn="l"/>
+            <a:r>
+              <a:rPr sz="2800" b="1">
+                <a:solidFill>
+                  <a:srgbClr val="FFFFFF"/>
+                </a:solidFill>
+              </a:rPr>
+              <a:t>The initialize handshake</a:t>
+            </a:r>
+          </a:p>
+        </p:txBody>
+      </p:sp>
+      <p:sp>
+        <p:nvSpPr>
+          <p:cNvPr id="5" name="Rectangle 4"/>
+          <p:cNvSpPr/>
+          <p:nvPr/>
+        </p:nvSpPr>
+        <p:spPr>
+          <a:xfrm>
+            <a:off x="457200" y="1143000"/>
+            <a:ext cx="11247120" cy="27432"/>
+          </a:xfrm>
+          <a:prstGeom prst="rect">
+            <a:avLst/>
+          </a:prstGeom>
+          <a:solidFill>
+            <a:srgbClr val="A1A1AA"/>
+          </a:solidFill>
+          <a:ln>
+            <a:noFill/>
+          </a:ln>
+        </p:spPr>
+        <p:style>
+          <a:lnRef idx="1">
+            <a:schemeClr val="accent1"/>
+          </a:lnRef>
+          <a:fillRef idx="3">
+            <a:schemeClr val="accent1"/>
+          </a:fillRef>
+          <a:effectRef idx="2">
+            <a:schemeClr val="accent1"/>
+          </a:effectRef>
+          <a:fontRef idx="minor">
+            <a:schemeClr val="lt1"/>
+          </a:fontRef>
+        </p:style>
+        <p:txBody>
+          <a:bodyPr rtlCol="0" anchor="ctr"/>
+          <a:lstStyle/>
+          <a:p>
+            <a:pPr algn="ctr"/>
+          </a:p>
+        </p:txBody>
+      </p:sp>
+      <p:sp>
+        <p:nvSpPr>
+          <p:cNvPr id="6" name="TextBox 5"/>
+          <p:cNvSpPr txBox="1"/>
+          <p:nvPr/>
+        </p:nvSpPr>
+        <p:spPr>
+          <a:xfrm>
+            <a:off x="502920" y="1298448"/>
+            <a:ext cx="11155680" cy="731520"/>
+          </a:xfrm>
+          <a:prstGeom prst="rect">
+            <a:avLst/>
+          </a:prstGeom>
+          <a:noFill/>
+        </p:spPr>
+        <p:txBody>
+          <a:bodyPr wrap="square">
+            <a:spAutoFit/>
+          </a:bodyPr>
+          <a:lstStyle/>
+          <a:p>
+            <a:pPr algn="l"/>
+            <a:r>
+              <a:rPr sz="1500" b="0">
+                <a:solidFill>
+                  <a:srgbClr val="FFFFFF"/>
+                </a:solidFill>
+              </a:rPr>
+              <a:t>▸  Every session begins: initialize request → initialize response → notifications/initialized</a:t>
+            </a:r>
+          </a:p>
+        </p:txBody>
+      </p:sp>
+      <p:sp>
+        <p:nvSpPr>
+          <p:cNvPr id="7" name="TextBox 6"/>
+          <p:cNvSpPr txBox="1"/>
+          <p:nvPr/>
+        </p:nvSpPr>
+        <p:spPr>
+          <a:xfrm>
+            <a:off x="502920" y="2121408"/>
+            <a:ext cx="11155680" cy="731520"/>
+          </a:xfrm>
+          <a:prstGeom prst="rect">
+            <a:avLst/>
+          </a:prstGeom>
+          <a:noFill/>
+        </p:spPr>
+        <p:txBody>
+          <a:bodyPr wrap="square">
+            <a:spAutoFit/>
+          </a:bodyPr>
+          <a:lstStyle/>
+          <a:p>
+            <a:pPr algn="l"/>
+            <a:r>
+              <a:rPr sz="1500" b="0">
+                <a:solidFill>
+                  <a:srgbClr val="FFFFFF"/>
+                </a:solidFill>
+              </a:rPr>
+              <a:t>▸  The handshake must complete before any tool calls — requests before it violate the spec</a:t>
+            </a:r>
+          </a:p>
+        </p:txBody>
+      </p:sp>
+      <p:sp>
+        <p:nvSpPr>
+          <p:cNvPr id="8" name="TextBox 7"/>
+          <p:cNvSpPr txBox="1"/>
+          <p:nvPr/>
+        </p:nvSpPr>
+        <p:spPr>
+          <a:xfrm>
+            <a:off x="502920" y="2944368"/>
+            <a:ext cx="11155680" cy="731520"/>
+          </a:xfrm>
+          <a:prstGeom prst="rect">
+            <a:avLst/>
+          </a:prstGeom>
+          <a:noFill/>
+        </p:spPr>
+        <p:txBody>
+          <a:bodyPr wrap="square">
+            <a:spAutoFit/>
+          </a:bodyPr>
+          <a:lstStyle/>
+          <a:p>
+            <a:pPr algn="l"/>
+            <a:r>
+              <a:rPr sz="1500" b="0">
+                <a:solidFill>
+                  <a:srgbClr val="FFFFFF"/>
+                </a:solidFill>
+              </a:rPr>
+              <a:t>▸  Each side’s capabilities object determines the entire valid call surface for the session</a:t>
+            </a:r>
+          </a:p>
+        </p:txBody>
+      </p:sp>
+      <p:sp>
+        <p:nvSpPr>
+          <p:cNvPr id="9" name="TextBox 8"/>
+          <p:cNvSpPr txBox="1"/>
+          <p:nvPr/>
+        </p:nvSpPr>
+        <p:spPr>
+          <a:xfrm>
+            <a:off x="502920" y="3767328"/>
+            <a:ext cx="11155680" cy="731520"/>
+          </a:xfrm>
+          <a:prstGeom prst="rect">
+            <a:avLst/>
+          </a:prstGeom>
+          <a:noFill/>
+        </p:spPr>
+        <p:txBody>
+          <a:bodyPr wrap="square">
+            <a:spAutoFit/>
+          </a:bodyPr>
+          <a:lstStyle/>
+          <a:p>
+            <a:pPr algn="l"/>
+            <a:r>
+              <a:rPr sz="1500" b="0">
+                <a:solidFill>
+                  <a:srgbClr val="FFFFFF"/>
+                </a:solidFill>
+              </a:rPr>
+              <a:t>▸  notifications/initialized is a notification — no id field, no response expected from server</a:t>
+            </a:r>
+          </a:p>
+        </p:txBody>
+      </p:sp>
+      <p:sp>
+        <p:nvSpPr>
+          <p:cNvPr id="10" name="TextBox 9"/>
+          <p:cNvSpPr txBox="1"/>
+          <p:nvPr/>
+        </p:nvSpPr>
+        <p:spPr>
+          <a:xfrm>
+            <a:off x="502920" y="4590288"/>
+            <a:ext cx="11155680" cy="731520"/>
+          </a:xfrm>
+          <a:prstGeom prst="rect">
+            <a:avLst/>
+          </a:prstGeom>
+          <a:noFill/>
+        </p:spPr>
+        <p:txBody>
+          <a:bodyPr wrap="square">
+            <a:spAutoFit/>
+          </a:bodyPr>
+          <a:lstStyle/>
+          <a:p>
+            <a:pPr algn="l"/>
+            <a:r>
+              <a:rPr sz="1500" b="0">
+                <a:solidFill>
+                  <a:srgbClr val="FFFFFF"/>
+                </a:solidFill>
+              </a:rPr>
+              <a:t>▸  Spec: https://spec.modelcontextprotocol.io/specification/2025-03-26/</a:t>
+            </a:r>
+          </a:p>
+        </p:txBody>
+      </p:sp>
+      <p:sp>
+        <p:nvSpPr>
+          <p:cNvPr id="11" name="TextBox 10"/>
+          <p:cNvSpPr txBox="1"/>
+          <p:nvPr/>
+        </p:nvSpPr>
+        <p:spPr>
+          <a:xfrm>
+            <a:off x="457200" y="6492240"/>
+            <a:ext cx="11247120" cy="320040"/>
+          </a:xfrm>
+          <a:prstGeom prst="rect">
+            <a:avLst/>
+          </a:prstGeom>
+          <a:noFill/>
+        </p:spPr>
+        <p:txBody>
+          <a:bodyPr wrap="square">
+            <a:spAutoFit/>
+          </a:bodyPr>
+          <a:lstStyle/>
+          <a:p>
+            <a:pPr algn="l"/>
+            <a:r>
+              <a:rPr sz="1000" b="0">
+                <a:solidFill>
+                  <a:srgbClr val="A1A1AA"/>
+                </a:solidFill>
+              </a:rPr>
+              <a:t>academy.kspl.tech | Koenig AI Academy</a:t>
+            </a:r>
+          </a:p>
+        </p:txBody>
+      </p:sp>
+    </p:spTree>
+  </p:cSld>
+  <p:clrMapOvr>
+    <a:masterClrMapping/>
+  </p:clrMapOvr>
+</p:sld>
+</file>
+
+<file path=ppt/slides/slide6.xml><?xml version="1.0" encoding="utf-8"?>
+<p:sld xmlns:a="http://schemas.openxmlformats.org/drawingml/2006/main" xmlns:p="http://schemas.openxmlformats.org/presentationml/2006/main" xmlns:r="http://schemas.openxmlformats.org/officeDocument/2006/relationships">
+  <p:cSld>
+    <p:spTree>
+      <p:nvGrpSpPr>
+        <p:cNvPr id="1" name=""/>
+        <p:cNvGrpSpPr/>
+        <p:nvPr/>
+      </p:nvGrpSpPr>
+      <p:grpSpPr/>
+      <p:sp>
+        <p:nvSpPr>
+          <p:cNvPr id="2" name="Rectangle 1"/>
+          <p:cNvSpPr/>
+          <p:nvPr/>
+        </p:nvSpPr>
+        <p:spPr>
+          <a:xfrm>
+            <a:off x="0" y="0"/>
+            <a:ext cx="12191695" cy="6858000"/>
+          </a:xfrm>
+          <a:prstGeom prst="rect">
+            <a:avLst/>
+          </a:prstGeom>
+          <a:solidFill>
+            <a:srgbClr val="18181B"/>
+          </a:solidFill>
+          <a:ln>
+            <a:noFill/>
+          </a:ln>
+        </p:spPr>
+        <p:style>
+          <a:lnRef idx="1">
+            <a:schemeClr val="accent1"/>
+          </a:lnRef>
+          <a:fillRef idx="3">
+            <a:schemeClr val="accent1"/>
+          </a:fillRef>
+          <a:effectRef idx="2">
+            <a:schemeClr val="accent1"/>
+          </a:effectRef>
+          <a:fontRef idx="minor">
+            <a:schemeClr val="lt1"/>
+          </a:fontRef>
+        </p:style>
+        <p:txBody>
+          <a:bodyPr rtlCol="0" anchor="ctr"/>
+          <a:lstStyle/>
+          <a:p>
+            <a:pPr algn="ctr"/>
+          </a:p>
+        </p:txBody>
+      </p:sp>
+      <p:sp>
+        <p:nvSpPr>
+          <p:cNvPr id="3" name="Rectangle 2"/>
+          <p:cNvSpPr/>
+          <p:nvPr/>
+        </p:nvSpPr>
+        <p:spPr>
+          <a:xfrm>
+            <a:off x="0" y="0"/>
+            <a:ext cx="12191695" cy="54864"/>
+          </a:xfrm>
+          <a:prstGeom prst="rect">
+            <a:avLst/>
+          </a:prstGeom>
+          <a:solidFill>
+            <a:srgbClr val="6366F1"/>
+          </a:solidFill>
+          <a:ln>
+            <a:noFill/>
+          </a:ln>
+        </p:spPr>
+        <p:style>
+          <a:lnRef idx="1">
+            <a:schemeClr val="accent1"/>
+          </a:lnRef>
+          <a:fillRef idx="3">
+            <a:schemeClr val="accent1"/>
+          </a:fillRef>
+          <a:effectRef idx="2">
+            <a:schemeClr val="accent1"/>
+          </a:effectRef>
+          <a:fontRef idx="minor">
+            <a:schemeClr val="lt1"/>
+          </a:fontRef>
+        </p:style>
+        <p:txBody>
+          <a:bodyPr rtlCol="0" anchor="ctr"/>
+          <a:lstStyle/>
+          <a:p>
+            <a:pPr algn="ctr"/>
+          </a:p>
+        </p:txBody>
+      </p:sp>
+      <p:sp>
+        <p:nvSpPr>
+          <p:cNvPr id="4" name="TextBox 3"/>
+          <p:cNvSpPr txBox="1"/>
+          <p:nvPr/>
+        </p:nvSpPr>
+        <p:spPr>
+          <a:xfrm>
+            <a:off x="457200" y="164592"/>
+            <a:ext cx="11247120" cy="868680"/>
+          </a:xfrm>
+          <a:prstGeom prst="rect">
+            <a:avLst/>
+          </a:prstGeom>
+          <a:noFill/>
+        </p:spPr>
+        <p:txBody>
+          <a:bodyPr wrap="square">
+            <a:spAutoFit/>
+          </a:bodyPr>
+          <a:lstStyle/>
+          <a:p>
+            <a:pPr algn="l"/>
+            <a:r>
+              <a:rPr sz="2800" b="1">
+                <a:solidFill>
+                  <a:srgbClr val="FFFFFF"/>
+                </a:solidFill>
+              </a:rPr>
+              <a:t>Reading a real MCP exchange</a:t>
+            </a:r>
+          </a:p>
+        </p:txBody>
+      </p:sp>
+      <p:sp>
+        <p:nvSpPr>
+          <p:cNvPr id="5" name="Rectangle 4"/>
+          <p:cNvSpPr/>
+          <p:nvPr/>
+        </p:nvSpPr>
+        <p:spPr>
+          <a:xfrm>
+            <a:off x="457200" y="1143000"/>
+            <a:ext cx="11247120" cy="27432"/>
+          </a:xfrm>
+          <a:prstGeom prst="rect">
+            <a:avLst/>
+          </a:prstGeom>
+          <a:solidFill>
+            <a:srgbClr val="A1A1AA"/>
+          </a:solidFill>
+          <a:ln>
+            <a:noFill/>
+          </a:ln>
+        </p:spPr>
+        <p:style>
+          <a:lnRef idx="1">
+            <a:schemeClr val="accent1"/>
+          </a:lnRef>
+          <a:fillRef idx="3">
+            <a:schemeClr val="accent1"/>
+          </a:fillRef>
+          <a:effectRef idx="2">
+            <a:schemeClr val="accent1"/>
+          </a:effectRef>
+          <a:fontRef idx="minor">
+            <a:schemeClr val="lt1"/>
+          </a:fontRef>
+        </p:style>
+        <p:txBody>
+          <a:bodyPr rtlCol="0" anchor="ctr"/>
+          <a:lstStyle/>
+          <a:p>
+            <a:pPr algn="ctr"/>
+          </a:p>
+        </p:txBody>
+      </p:sp>
+      <p:sp>
+        <p:nvSpPr>
+          <p:cNvPr id="6" name="TextBox 5"/>
+          <p:cNvSpPr txBox="1"/>
+          <p:nvPr/>
+        </p:nvSpPr>
+        <p:spPr>
+          <a:xfrm>
+            <a:off x="502920" y="1298448"/>
+            <a:ext cx="11155680" cy="731520"/>
+          </a:xfrm>
+          <a:prstGeom prst="rect">
+            <a:avLst/>
+          </a:prstGeom>
+          <a:noFill/>
+        </p:spPr>
+        <p:txBody>
+          <a:bodyPr wrap="square">
+            <a:spAutoFit/>
+          </a:bodyPr>
+          <a:lstStyle/>
+          <a:p>
+            <a:pPr algn="l"/>
+            <a:r>
+              <a:rPr sz="1500" b="0">
+                <a:solidFill>
+                  <a:srgbClr val="FFFFFF"/>
+                </a:solidFill>
+              </a:rPr>
+              <a:t>▸  Scenario: user asks about open GitHub PRs; host invokes list_pull_requests on an MCP server</a:t>
+            </a:r>
+          </a:p>
+        </p:txBody>
+      </p:sp>
+      <p:sp>
+        <p:nvSpPr>
+          <p:cNvPr id="7" name="TextBox 6"/>
+          <p:cNvSpPr txBox="1"/>
+          <p:nvPr/>
+        </p:nvSpPr>
+        <p:spPr>
+          <a:xfrm>
+            <a:off x="502920" y="2121408"/>
+            <a:ext cx="11155680" cy="731520"/>
+          </a:xfrm>
+          <a:prstGeom prst="rect">
+            <a:avLst/>
+          </a:prstGeom>
+          <a:noFill/>
+        </p:spPr>
+        <p:txBody>
+          <a:bodyPr wrap="square">
+            <a:spAutoFit/>
+          </a:bodyPr>
+          <a:lstStyle/>
+          <a:p>
+            <a:pPr algn="l"/>
+            <a:r>
+              <a:rPr sz="1500" b="0">
+                <a:solidFill>
+                  <a:srgbClr val="FFFFFF"/>
+                </a:solidFill>
+              </a:rPr>
+              <a:t>▸  Step 1: host sends tools/list to discover available tools and each tool’s inputSchema</a:t>
+            </a:r>
+          </a:p>
+        </p:txBody>
+      </p:sp>
+      <p:sp>
+        <p:nvSpPr>
+          <p:cNvPr id="8" name="TextBox 7"/>
+          <p:cNvSpPr txBox="1"/>
+          <p:nvPr/>
+        </p:nvSpPr>
+        <p:spPr>
+          <a:xfrm>
+            <a:off x="502920" y="2944368"/>
+            <a:ext cx="11155680" cy="731520"/>
+          </a:xfrm>
+          <a:prstGeom prst="rect">
+            <a:avLst/>
+          </a:prstGeom>
+          <a:noFill/>
+        </p:spPr>
+        <p:txBody>
+          <a:bodyPr wrap="square">
+            <a:spAutoFit/>
+          </a:bodyPr>
+          <a:lstStyle/>
+          <a:p>
+            <a:pPr algn="l"/>
+            <a:r>
+              <a:rPr sz="1500" b="0">
+                <a:solidFill>
+                  <a:srgbClr val="FFFFFF"/>
+                </a:solidFill>
+              </a:rPr>
+              <a:t>▸  Step 2: model decides to call a tool; host sends tools/call with name and arguments</a:t>
+            </a:r>
+          </a:p>
+        </p:txBody>
+      </p:sp>
+      <p:sp>
+        <p:nvSpPr>
+          <p:cNvPr id="9" name="TextBox 8"/>
+          <p:cNvSpPr txBox="1"/>
+          <p:nvPr/>
+        </p:nvSpPr>
+        <p:spPr>
+          <a:xfrm>
+            <a:off x="502920" y="3767328"/>
+            <a:ext cx="11155680" cy="731520"/>
+          </a:xfrm>
+          <a:prstGeom prst="rect">
+            <a:avLst/>
+          </a:prstGeom>
+          <a:noFill/>
+        </p:spPr>
+        <p:txBody>
+          <a:bodyPr wrap="square">
+            <a:spAutoFit/>
+          </a:bodyPr>
+          <a:lstStyle/>
+          <a:p>
+            <a:pPr algn="l"/>
+            <a:r>
+              <a:rPr sz="1500" b="0">
+                <a:solidFill>
+                  <a:srgbClr val="FFFFFF"/>
+                </a:solidFill>
+              </a:rPr>
+              <a:t>▸  Tool errors use isError:true in result — JSON-RPC error field is for protocol errors only</a:t>
+            </a:r>
+          </a:p>
+        </p:txBody>
+      </p:sp>
+      <p:sp>
+        <p:nvSpPr>
+          <p:cNvPr id="10" name="TextBox 9"/>
+          <p:cNvSpPr txBox="1"/>
+          <p:nvPr/>
+        </p:nvSpPr>
+        <p:spPr>
+          <a:xfrm>
+            <a:off x="502920" y="4590288"/>
+            <a:ext cx="11155680" cy="731520"/>
+          </a:xfrm>
+          <a:prstGeom prst="rect">
+            <a:avLst/>
+          </a:prstGeom>
+          <a:noFill/>
+        </p:spPr>
+        <p:txBody>
+          <a:bodyPr wrap="square">
+            <a:spAutoFit/>
+          </a:bodyPr>
+          <a:lstStyle/>
+          <a:p>
+            <a:pPr algn="l"/>
+            <a:r>
+              <a:rPr sz="1500" b="0">
+                <a:solidFill>
+                  <a:srgbClr val="FFFFFF"/>
+                </a:solidFill>
+              </a:rPr>
+              <a:t>▸  Protocol errors (malformed request) and tool errors (execution failed) are handled differently</a:t>
+            </a:r>
+          </a:p>
+        </p:txBody>
+      </p:sp>
+      <p:sp>
+        <p:nvSpPr>
+          <p:cNvPr id="11" name="TextBox 10"/>
+          <p:cNvSpPr txBox="1"/>
+          <p:nvPr/>
+        </p:nvSpPr>
+        <p:spPr>
+          <a:xfrm>
+            <a:off x="457200" y="6492240"/>
+            <a:ext cx="11247120" cy="320040"/>
           </a:xfrm>
           <a:prstGeom prst="rect">
             <a:avLst/>
@@ -4512,14 +5219,6 @@
 <file path=ppt/slides/slide7.xml><?xml version="1.0" encoding="utf-8"?>
 <p:sld xmlns:a="http://schemas.openxmlformats.org/drawingml/2006/main" xmlns:p="http://schemas.openxmlformats.org/presentationml/2006/main" xmlns:r="http://schemas.openxmlformats.org/officeDocument/2006/relationships">
   <p:cSld>
-    <p:bg>
-      <p:bgPr>
-        <a:solidFill>
-          <a:srgbClr val="18181B"/>
-        </a:solidFill>
-        <a:effectLst/>
-      </p:bgPr>
-    </p:bg>
     <p:spTree>
       <p:nvGrpSpPr>
         <p:cNvPr id="1" name=""/>
@@ -4529,14 +5228,100 @@
       <p:grpSpPr/>
       <p:sp>
         <p:nvSpPr>
-          <p:cNvPr id="2" name="TextBox 1"/>
+          <p:cNvPr id="2" name="Rectangle 1"/>
+          <p:cNvSpPr/>
+          <p:nvPr/>
+        </p:nvSpPr>
+        <p:spPr>
+          <a:xfrm>
+            <a:off x="0" y="0"/>
+            <a:ext cx="12191695" cy="6858000"/>
+          </a:xfrm>
+          <a:prstGeom prst="rect">
+            <a:avLst/>
+          </a:prstGeom>
+          <a:solidFill>
+            <a:srgbClr val="18181B"/>
+          </a:solidFill>
+          <a:ln>
+            <a:noFill/>
+          </a:ln>
+        </p:spPr>
+        <p:style>
+          <a:lnRef idx="1">
+            <a:schemeClr val="accent1"/>
+          </a:lnRef>
+          <a:fillRef idx="3">
+            <a:schemeClr val="accent1"/>
+          </a:fillRef>
+          <a:effectRef idx="2">
+            <a:schemeClr val="accent1"/>
+          </a:effectRef>
+          <a:fontRef idx="minor">
+            <a:schemeClr val="lt1"/>
+          </a:fontRef>
+        </p:style>
+        <p:txBody>
+          <a:bodyPr rtlCol="0" anchor="ctr"/>
+          <a:lstStyle/>
+          <a:p>
+            <a:pPr algn="ctr"/>
+          </a:p>
+        </p:txBody>
+      </p:sp>
+      <p:sp>
+        <p:nvSpPr>
+          <p:cNvPr id="3" name="Rectangle 2"/>
+          <p:cNvSpPr/>
+          <p:nvPr/>
+        </p:nvSpPr>
+        <p:spPr>
+          <a:xfrm>
+            <a:off x="0" y="0"/>
+            <a:ext cx="54864" cy="6858000"/>
+          </a:xfrm>
+          <a:prstGeom prst="rect">
+            <a:avLst/>
+          </a:prstGeom>
+          <a:solidFill>
+            <a:srgbClr val="6366F1"/>
+          </a:solidFill>
+          <a:ln>
+            <a:noFill/>
+          </a:ln>
+        </p:spPr>
+        <p:style>
+          <a:lnRef idx="1">
+            <a:schemeClr val="accent1"/>
+          </a:lnRef>
+          <a:fillRef idx="3">
+            <a:schemeClr val="accent1"/>
+          </a:fillRef>
+          <a:effectRef idx="2">
+            <a:schemeClr val="accent1"/>
+          </a:effectRef>
+          <a:fontRef idx="minor">
+            <a:schemeClr val="lt1"/>
+          </a:fontRef>
+        </p:style>
+        <p:txBody>
+          <a:bodyPr rtlCol="0" anchor="ctr"/>
+          <a:lstStyle/>
+          <a:p>
+            <a:pPr algn="ctr"/>
+          </a:p>
+        </p:txBody>
+      </p:sp>
+      <p:sp>
+        <p:nvSpPr>
+          <p:cNvPr id="4" name="TextBox 3"/>
           <p:cNvSpPr txBox="1"/>
           <p:nvPr/>
         </p:nvSpPr>
         <p:spPr>
           <a:xfrm>
-            <a:off x="914400" y="2011680"/>
-            <a:ext cx="10332720" cy="914400"/>
+            <a:off x="914400" y="1828800"/>
+            <a:ext cx="10332720" cy="731520"/>
           </a:xfrm>
           <a:prstGeom prst="rect">
             <a:avLst/>
@@ -4551,26 +5336,26 @@
           <a:p>
             <a:pPr algn="ctr"/>
             <a:r>
-              <a:rPr sz="3400" b="1">
+              <a:rPr sz="3600" b="1">
                 <a:solidFill>
                   <a:srgbClr val="FFFFFF"/>
                 </a:solidFill>
               </a:rPr>
-              <a:t>Try it next</a:t>
-            </a:r>
-          </a:p>
-        </p:txBody>
-      </p:sp>
-      <p:sp>
-        <p:nvSpPr>
-          <p:cNvPr id="3" name="TextBox 2"/>
+              <a:t>Try It Next</a:t>
+            </a:r>
+          </a:p>
+        </p:txBody>
+      </p:sp>
+      <p:sp>
+        <p:nvSpPr>
+          <p:cNvPr id="5" name="TextBox 4"/>
           <p:cNvSpPr txBox="1"/>
           <p:nvPr/>
         </p:nvSpPr>
         <p:spPr>
           <a:xfrm>
-            <a:off x="914400" y="3200400"/>
-            <a:ext cx="10332720" cy="1097280"/>
+            <a:off x="914400" y="2743200"/>
+            <a:ext cx="10332720" cy="640080"/>
           </a:xfrm>
           <a:prstGeom prst="rect">
             <a:avLst/>
@@ -4590,21 +5375,21 @@
                   <a:srgbClr val="A1A1AA"/>
                 </a:solidFill>
               </a:rPr>
-              <a:t>Deploy a gateway with RBAC, rate limits, and JSONL auditing</a:t>
-            </a:r>
-          </a:p>
-        </p:txBody>
-      </p:sp>
-      <p:sp>
-        <p:nvSpPr>
-          <p:cNvPr id="4" name="TextBox 3"/>
+              <a:t>Write a 60-line Python MCP server — no SDK, raw sys.stdin / sys.stdout</a:t>
+            </a:r>
+          </a:p>
+        </p:txBody>
+      </p:sp>
+      <p:sp>
+        <p:nvSpPr>
+          <p:cNvPr id="6" name="TextBox 5"/>
           <p:cNvSpPr txBox="1"/>
           <p:nvPr/>
         </p:nvSpPr>
         <p:spPr>
           <a:xfrm>
-            <a:off x="731520" y="6263640"/>
-            <a:ext cx="10698480" cy="365760"/>
+            <a:off x="914400" y="3840480"/>
+            <a:ext cx="10332720" cy="457200"/>
           </a:xfrm>
           <a:prstGeom prst="rect">
             <a:avLst/>
@@ -4617,11 +5402,11 @@
           </a:bodyPr>
           <a:lstStyle/>
           <a:p>
-            <a:pPr algn="l"/>
-            <a:r>
-              <a:rPr sz="1000" b="0">
-                <a:solidFill>
-                  <a:srgbClr val="A1A1AA"/>
+            <a:pPr algn="ctr"/>
+            <a:r>
+              <a:rPr sz="1600" b="0">
+                <a:solidFill>
+                  <a:srgbClr val="6366F1"/>
                 </a:solidFill>
               </a:rPr>
               <a:t>academy.kspl.tech | Koenig AI Academy</a:t>

</xml_diff>